<commit_message>
Update Book Two to enhanced version (37 slides, spelling fixes + practice)
</commit_message>
<xml_diff>
--- a/books/book-two-raw-english.pptx
+++ b/books/book-two-raw-english.pptx
@@ -15,27 +15,39 @@
     <p:sldId id="302" r:id="rId3"/>
     <p:sldId id="260" r:id="rId4"/>
     <p:sldId id="264" r:id="rId5"/>
+    <p:sldId id="303" r:id="rId33"/>
     <p:sldId id="262" r:id="rId6"/>
     <p:sldId id="261" r:id="rId7"/>
+    <p:sldId id="304" r:id="rId34"/>
     <p:sldId id="263" r:id="rId8"/>
     <p:sldId id="284" r:id="rId9"/>
+    <p:sldId id="305" r:id="rId35"/>
     <p:sldId id="285" r:id="rId10"/>
     <p:sldId id="286" r:id="rId11"/>
+    <p:sldId id="306" r:id="rId36"/>
     <p:sldId id="287" r:id="rId12"/>
     <p:sldId id="291" r:id="rId13"/>
+    <p:sldId id="307" r:id="rId37"/>
     <p:sldId id="289" r:id="rId14"/>
     <p:sldId id="288" r:id="rId15"/>
+    <p:sldId id="308" r:id="rId38"/>
     <p:sldId id="292" r:id="rId16"/>
     <p:sldId id="290" r:id="rId17"/>
+    <p:sldId id="309" r:id="rId39"/>
     <p:sldId id="293" r:id="rId18"/>
     <p:sldId id="294" r:id="rId19"/>
+    <p:sldId id="310" r:id="rId40"/>
     <p:sldId id="299" r:id="rId20"/>
     <p:sldId id="300" r:id="rId21"/>
+    <p:sldId id="311" r:id="rId41"/>
     <p:sldId id="297" r:id="rId22"/>
     <p:sldId id="298" r:id="rId23"/>
+    <p:sldId id="312" r:id="rId42"/>
     <p:sldId id="295" r:id="rId24"/>
     <p:sldId id="296" r:id="rId25"/>
+    <p:sldId id="313" r:id="rId43"/>
     <p:sldId id="301" r:id="rId26"/>
+    <p:sldId id="314" r:id="rId44"/>
   </p:sldIdLst>
   <p:sldSz cx="12192000" cy="6858000"/>
   <p:notesSz cx="6858000" cy="9144000"/>
@@ -11762,7 +11774,7 @@
                   <a:schemeClr val="bg1"/>
                 </a:solidFill>
               </a:rPr>
-              <a:t>Kitchen</a:t>
+              <a:t>kitchen</a:t>
             </a:r>
             <a:r>
               <a:rPr lang="pt-BR" sz="2000" dirty="0">
@@ -14250,7 +14262,7 @@
                   <a:schemeClr val="bg1"/>
                 </a:solidFill>
               </a:rPr>
-              <a:t>grandaughter</a:t>
+              <a:t>granddaughter</a:t>
             </a:r>
             <a:r>
               <a:rPr lang="pt-BR" sz="2400" dirty="0">
@@ -14458,7 +14470,7 @@
                   <a:schemeClr val="bg1"/>
                 </a:solidFill>
               </a:rPr>
-              <a:t>chinese</a:t>
+              <a:t>Chinese</a:t>
             </a:r>
             <a:r>
               <a:rPr lang="pt-BR" sz="2400" dirty="0">
@@ -19981,7 +19993,7 @@
                   <a:schemeClr val="bg1"/>
                 </a:solidFill>
               </a:rPr>
-              <a:t>grandaughter</a:t>
+              <a:t>granddaughter</a:t>
             </a:r>
             <a:r>
               <a:rPr lang="pt-BR" dirty="0">
@@ -20189,7 +20201,7 @@
                   <a:schemeClr val="bg1"/>
                 </a:solidFill>
               </a:rPr>
-              <a:t>chinese</a:t>
+              <a:t>Chinese</a:t>
             </a:r>
             <a:r>
               <a:rPr lang="pt-BR" dirty="0">
@@ -21443,7 +21455,7 @@
                   <a:schemeClr val="bg1"/>
                 </a:solidFill>
               </a:rPr>
-              <a:t>understand-undertood</a:t>
+              <a:t>understand-understood</a:t>
             </a:r>
             <a:r>
               <a:rPr lang="pt-BR" sz="3200" dirty="0">
@@ -22884,6 +22896,1318 @@
 </p:sld>
 </file>
 
+<file path=ppt/slides/slide26.xml><?xml version="1.0" encoding="utf-8"?>
+<p:sld xmlns:a="http://schemas.openxmlformats.org/drawingml/2006/main" xmlns:p="http://schemas.openxmlformats.org/presentationml/2006/main" xmlns:r="http://schemas.openxmlformats.org/officeDocument/2006/relationships">
+  <p:cSld>
+    <p:spTree>
+      <p:nvGrpSpPr>
+        <p:cNvPr id="1" name=""/>
+        <p:cNvGrpSpPr/>
+        <p:nvPr/>
+      </p:nvGrpSpPr>
+      <p:grpSpPr/>
+      <p:sp>
+        <p:nvSpPr>
+          <p:cNvPr id="2" name="TextBox 1"/>
+          <p:cNvSpPr txBox="1"/>
+          <p:nvPr/>
+        </p:nvSpPr>
+        <p:spPr>
+          <a:xfrm>
+            <a:off x="914400" y="457200"/>
+            <a:ext cx="7772400" cy="731520"/>
+          </a:xfrm>
+          <a:prstGeom prst="rect">
+            <a:avLst/>
+          </a:prstGeom>
+          <a:noFill/>
+        </p:spPr>
+        <p:txBody>
+          <a:bodyPr wrap="none">
+            <a:spAutoFit/>
+          </a:bodyPr>
+          <a:lstStyle/>
+          <a:p>
+            <a:pPr algn="ctr"/>
+            <a:r>
+              <a:rPr sz="2800" b="1">
+                <a:solidFill>
+                  <a:srgbClr val="333333"/>
+                </a:solidFill>
+              </a:rPr>
+              <a:t>Lesson 1</a:t>
+            </a:r>
+          </a:p>
+        </p:txBody>
+      </p:sp>
+      <p:sp>
+        <p:nvSpPr>
+          <p:cNvPr id="3" name="TextBox 2"/>
+          <p:cNvSpPr txBox="1"/>
+          <p:nvPr/>
+        </p:nvSpPr>
+        <p:spPr>
+          <a:xfrm>
+            <a:off x="914400" y="1097280"/>
+            <a:ext cx="7772400" cy="548640"/>
+          </a:xfrm>
+          <a:prstGeom prst="rect">
+            <a:avLst/>
+          </a:prstGeom>
+          <a:noFill/>
+        </p:spPr>
+        <p:txBody>
+          <a:bodyPr wrap="none">
+            <a:spAutoFit/>
+          </a:bodyPr>
+          <a:lstStyle/>
+          <a:p>
+            <a:pPr algn="ctr"/>
+            <a:r>
+              <a:rPr sz="2400" b="1">
+                <a:solidFill>
+                  <a:srgbClr val="E86C00"/>
+                </a:solidFill>
+              </a:rPr>
+              <a:t>PRACTICE / PRATIQUE</a:t>
+            </a:r>
+          </a:p>
+        </p:txBody>
+      </p:sp>
+      <p:sp>
+        <p:nvSpPr>
+          <p:cNvPr id="4" name="TextBox 3"/>
+          <p:cNvSpPr txBox="1"/>
+          <p:nvPr/>
+        </p:nvSpPr>
+        <p:spPr>
+          <a:xfrm>
+            <a:off x="1097280" y="1645920"/>
+            <a:ext cx="9144000" cy="4114800"/>
+          </a:xfrm>
+          <a:prstGeom prst="rect">
+            <a:avLst/>
+          </a:prstGeom>
+          <a:noFill/>
+        </p:spPr>
+        <p:txBody>
+          <a:bodyPr wrap="square" anchor="t">
+            <a:spAutoFit/>
+          </a:bodyPr>
+          <a:lstStyle/>
+          <a:p>
+            <a:r>
+              <a:rPr sz="1800" b="1">
+                <a:solidFill>
+                  <a:srgbClr val="1A1A1A"/>
+                </a:solidFill>
+              </a:rPr>
+              <a:t>▸ I needed a new coat yesterday.</a:t>
+            </a:r>
+          </a:p>
+          <a:p>
+            <a:pPr>
+              <a:spcAft>
+                <a:spcPts val="1000"/>
+              </a:spcAft>
+            </a:pPr>
+            <a:r>
+              <a:rPr sz="1500" i="1">
+                <a:solidFill>
+                  <a:srgbClr val="777777"/>
+                </a:solidFill>
+              </a:rPr>
+              <a:t>   Eu precisei de um casaco novo ontem.</a:t>
+            </a:r>
+          </a:p>
+          <a:p>
+            <a:pPr>
+              <a:spcAft>
+                <a:spcPts val="1000"/>
+              </a:spcAft>
+            </a:pPr>
+          </a:p>
+          <a:p>
+            <a:r>
+              <a:rPr sz="1800" b="1">
+                <a:solidFill>
+                  <a:srgbClr val="1A1A1A"/>
+                </a:solidFill>
+              </a:rPr>
+              <a:t>▸ She traveled to Brazil last year.</a:t>
+            </a:r>
+          </a:p>
+          <a:p>
+            <a:pPr>
+              <a:spcAft>
+                <a:spcPts val="1000"/>
+              </a:spcAft>
+            </a:pPr>
+            <a:r>
+              <a:rPr sz="1500" i="1">
+                <a:solidFill>
+                  <a:srgbClr val="777777"/>
+                </a:solidFill>
+              </a:rPr>
+              <a:t>   Ela viajou para o Brasil ano passado.</a:t>
+            </a:r>
+          </a:p>
+          <a:p>
+            <a:pPr>
+              <a:spcAft>
+                <a:spcPts val="1000"/>
+              </a:spcAft>
+            </a:pPr>
+          </a:p>
+          <a:p>
+            <a:r>
+              <a:rPr sz="1800" b="1">
+                <a:solidFill>
+                  <a:srgbClr val="1A1A1A"/>
+                </a:solidFill>
+              </a:rPr>
+              <a:t>▸ He bought a shirt for his neighbor.</a:t>
+            </a:r>
+          </a:p>
+          <a:p>
+            <a:pPr>
+              <a:spcAft>
+                <a:spcPts val="1000"/>
+              </a:spcAft>
+            </a:pPr>
+            <a:r>
+              <a:rPr sz="1500" i="1">
+                <a:solidFill>
+                  <a:srgbClr val="777777"/>
+                </a:solidFill>
+              </a:rPr>
+              <a:t>   Ele comprou uma camisa para o vizinho.</a:t>
+            </a:r>
+          </a:p>
+          <a:p>
+            <a:pPr>
+              <a:spcAft>
+                <a:spcPts val="1000"/>
+              </a:spcAft>
+            </a:pPr>
+          </a:p>
+          <a:p>
+            <a:r>
+              <a:rPr sz="1800" b="1">
+                <a:solidFill>
+                  <a:srgbClr val="1A1A1A"/>
+                </a:solidFill>
+              </a:rPr>
+              <a:t>▸ We sold the furniture last month.</a:t>
+            </a:r>
+          </a:p>
+          <a:p>
+            <a:pPr>
+              <a:spcAft>
+                <a:spcPts val="1000"/>
+              </a:spcAft>
+            </a:pPr>
+            <a:r>
+              <a:rPr sz="1500" i="1">
+                <a:solidFill>
+                  <a:srgbClr val="777777"/>
+                </a:solidFill>
+              </a:rPr>
+              <a:t>   Nós vendemos os móveis mês passado.</a:t>
+            </a:r>
+          </a:p>
+          <a:p>
+            <a:pPr>
+              <a:spcAft>
+                <a:spcPts val="1000"/>
+              </a:spcAft>
+            </a:pPr>
+          </a:p>
+          <a:p>
+            <a:r>
+              <a:rPr sz="1800" b="1">
+                <a:solidFill>
+                  <a:srgbClr val="1A1A1A"/>
+                </a:solidFill>
+              </a:rPr>
+              <a:t>▸ I was happy and she was sad.</a:t>
+            </a:r>
+          </a:p>
+          <a:p>
+            <a:pPr>
+              <a:spcAft>
+                <a:spcPts val="1000"/>
+              </a:spcAft>
+            </a:pPr>
+            <a:r>
+              <a:rPr sz="1500" i="1">
+                <a:solidFill>
+                  <a:srgbClr val="777777"/>
+                </a:solidFill>
+              </a:rPr>
+              <a:t>   Eu estava feliz e ela estava triste.</a:t>
+            </a:r>
+          </a:p>
+          <a:p>
+            <a:pPr>
+              <a:spcAft>
+                <a:spcPts val="1000"/>
+              </a:spcAft>
+            </a:pPr>
+          </a:p>
+          <a:p>
+            <a:r>
+              <a:rPr sz="1800" b="1">
+                <a:solidFill>
+                  <a:srgbClr val="1A1A1A"/>
+                </a:solidFill>
+              </a:rPr>
+              <a:t>▸ They were tired and slow.</a:t>
+            </a:r>
+          </a:p>
+          <a:p>
+            <a:pPr>
+              <a:spcAft>
+                <a:spcPts val="1000"/>
+              </a:spcAft>
+            </a:pPr>
+            <a:r>
+              <a:rPr sz="1500" i="1">
+                <a:solidFill>
+                  <a:srgbClr val="777777"/>
+                </a:solidFill>
+              </a:rPr>
+              <a:t>   Eles estavam cansados e lentos.</a:t>
+            </a:r>
+          </a:p>
+        </p:txBody>
+      </p:sp>
+      <p:sp>
+        <p:nvSpPr>
+          <p:cNvPr id="5" name="TextBox 4"/>
+          <p:cNvSpPr txBox="1"/>
+          <p:nvPr/>
+        </p:nvSpPr>
+        <p:spPr>
+          <a:xfrm>
+            <a:off x="914400" y="6309360"/>
+            <a:ext cx="7772400" cy="457200"/>
+          </a:xfrm>
+          <a:prstGeom prst="rect">
+            <a:avLst/>
+          </a:prstGeom>
+          <a:noFill/>
+        </p:spPr>
+        <p:txBody>
+          <a:bodyPr wrap="none">
+            <a:spAutoFit/>
+          </a:bodyPr>
+          <a:lstStyle/>
+          <a:p>
+            <a:pPr algn="ctr"/>
+            <a:r>
+              <a:rPr sz="1200">
+                <a:solidFill>
+                  <a:srgbClr val="999999"/>
+                </a:solidFill>
+              </a:rPr>
+              <a:t>www.rawenglish.com.br</a:t>
+            </a:r>
+          </a:p>
+        </p:txBody>
+      </p:sp>
+    </p:spTree>
+  </p:cSld>
+  <p:clrMapOvr>
+    <a:masterClrMapping/>
+  </p:clrMapOvr>
+</p:sld>
+</file>
+
+<file path=ppt/slides/slide27.xml><?xml version="1.0" encoding="utf-8"?>
+<p:sld xmlns:a="http://schemas.openxmlformats.org/drawingml/2006/main" xmlns:p="http://schemas.openxmlformats.org/presentationml/2006/main" xmlns:r="http://schemas.openxmlformats.org/officeDocument/2006/relationships">
+  <p:cSld>
+    <p:spTree>
+      <p:nvGrpSpPr>
+        <p:cNvPr id="1" name=""/>
+        <p:cNvGrpSpPr/>
+        <p:nvPr/>
+      </p:nvGrpSpPr>
+      <p:grpSpPr/>
+      <p:sp>
+        <p:nvSpPr>
+          <p:cNvPr id="2" name="TextBox 1"/>
+          <p:cNvSpPr txBox="1"/>
+          <p:nvPr/>
+        </p:nvSpPr>
+        <p:spPr>
+          <a:xfrm>
+            <a:off x="914400" y="457200"/>
+            <a:ext cx="7772400" cy="731520"/>
+          </a:xfrm>
+          <a:prstGeom prst="rect">
+            <a:avLst/>
+          </a:prstGeom>
+          <a:noFill/>
+        </p:spPr>
+        <p:txBody>
+          <a:bodyPr wrap="none">
+            <a:spAutoFit/>
+          </a:bodyPr>
+          <a:lstStyle/>
+          <a:p>
+            <a:pPr algn="ctr"/>
+            <a:r>
+              <a:rPr sz="2800" b="1">
+                <a:solidFill>
+                  <a:srgbClr val="333333"/>
+                </a:solidFill>
+              </a:rPr>
+              <a:t>Lesson 2</a:t>
+            </a:r>
+          </a:p>
+        </p:txBody>
+      </p:sp>
+      <p:sp>
+        <p:nvSpPr>
+          <p:cNvPr id="3" name="TextBox 2"/>
+          <p:cNvSpPr txBox="1"/>
+          <p:nvPr/>
+        </p:nvSpPr>
+        <p:spPr>
+          <a:xfrm>
+            <a:off x="914400" y="1097280"/>
+            <a:ext cx="7772400" cy="548640"/>
+          </a:xfrm>
+          <a:prstGeom prst="rect">
+            <a:avLst/>
+          </a:prstGeom>
+          <a:noFill/>
+        </p:spPr>
+        <p:txBody>
+          <a:bodyPr wrap="none">
+            <a:spAutoFit/>
+          </a:bodyPr>
+          <a:lstStyle/>
+          <a:p>
+            <a:pPr algn="ctr"/>
+            <a:r>
+              <a:rPr sz="2400" b="1">
+                <a:solidFill>
+                  <a:srgbClr val="E86C00"/>
+                </a:solidFill>
+              </a:rPr>
+              <a:t>PRACTICE / PRATIQUE</a:t>
+            </a:r>
+          </a:p>
+        </p:txBody>
+      </p:sp>
+      <p:sp>
+        <p:nvSpPr>
+          <p:cNvPr id="4" name="TextBox 3"/>
+          <p:cNvSpPr txBox="1"/>
+          <p:nvPr/>
+        </p:nvSpPr>
+        <p:spPr>
+          <a:xfrm>
+            <a:off x="1097280" y="1645920"/>
+            <a:ext cx="9144000" cy="4114800"/>
+          </a:xfrm>
+          <a:prstGeom prst="rect">
+            <a:avLst/>
+          </a:prstGeom>
+          <a:noFill/>
+        </p:spPr>
+        <p:txBody>
+          <a:bodyPr wrap="square" anchor="t">
+            <a:spAutoFit/>
+          </a:bodyPr>
+          <a:lstStyle/>
+          <a:p>
+            <a:r>
+              <a:rPr sz="1800" b="1">
+                <a:solidFill>
+                  <a:srgbClr val="1A1A1A"/>
+                </a:solidFill>
+              </a:rPr>
+              <a:t>▸ I liked the exercise yesterday.</a:t>
+            </a:r>
+          </a:p>
+          <a:p>
+            <a:pPr>
+              <a:spcAft>
+                <a:spcPts val="1000"/>
+              </a:spcAft>
+            </a:pPr>
+            <a:r>
+              <a:rPr sz="1500" i="1">
+                <a:solidFill>
+                  <a:srgbClr val="777777"/>
+                </a:solidFill>
+              </a:rPr>
+              <a:t>   Eu gostei do exercício ontem.</a:t>
+            </a:r>
+          </a:p>
+          <a:p>
+            <a:pPr>
+              <a:spcAft>
+                <a:spcPts val="1000"/>
+              </a:spcAft>
+            </a:pPr>
+          </a:p>
+          <a:p>
+            <a:r>
+              <a:rPr sz="1800" b="1">
+                <a:solidFill>
+                  <a:srgbClr val="1A1A1A"/>
+                </a:solidFill>
+              </a:rPr>
+              <a:t>▸ She slept very well last night.</a:t>
+            </a:r>
+          </a:p>
+          <a:p>
+            <a:pPr>
+              <a:spcAft>
+                <a:spcPts val="1000"/>
+              </a:spcAft>
+            </a:pPr>
+            <a:r>
+              <a:rPr sz="1500" i="1">
+                <a:solidFill>
+                  <a:srgbClr val="777777"/>
+                </a:solidFill>
+              </a:rPr>
+              <a:t>   Ela dormiu muito bem ontem à noite.</a:t>
+            </a:r>
+          </a:p>
+          <a:p>
+            <a:pPr>
+              <a:spcAft>
+                <a:spcPts val="1000"/>
+              </a:spcAft>
+            </a:pPr>
+          </a:p>
+          <a:p>
+            <a:r>
+              <a:rPr sz="1800" b="1">
+                <a:solidFill>
+                  <a:srgbClr val="1A1A1A"/>
+                </a:solidFill>
+              </a:rPr>
+              <a:t>▸ He started a new business.</a:t>
+            </a:r>
+          </a:p>
+          <a:p>
+            <a:pPr>
+              <a:spcAft>
+                <a:spcPts val="1000"/>
+              </a:spcAft>
+            </a:pPr>
+            <a:r>
+              <a:rPr sz="1500" i="1">
+                <a:solidFill>
+                  <a:srgbClr val="777777"/>
+                </a:solidFill>
+              </a:rPr>
+              <a:t>   Ele começou um novo negócio.</a:t>
+            </a:r>
+          </a:p>
+          <a:p>
+            <a:pPr>
+              <a:spcAft>
+                <a:spcPts val="1000"/>
+              </a:spcAft>
+            </a:pPr>
+          </a:p>
+          <a:p>
+            <a:r>
+              <a:rPr sz="1800" b="1">
+                <a:solidFill>
+                  <a:srgbClr val="1A1A1A"/>
+                </a:solidFill>
+              </a:rPr>
+              <a:t>▸ I finished already.</a:t>
+            </a:r>
+          </a:p>
+          <a:p>
+            <a:pPr>
+              <a:spcAft>
+                <a:spcPts val="1000"/>
+              </a:spcAft>
+            </a:pPr>
+            <a:r>
+              <a:rPr sz="1500" i="1">
+                <a:solidFill>
+                  <a:srgbClr val="777777"/>
+                </a:solidFill>
+              </a:rPr>
+              <a:t>   Eu já terminei.</a:t>
+            </a:r>
+          </a:p>
+          <a:p>
+            <a:pPr>
+              <a:spcAft>
+                <a:spcPts val="1000"/>
+              </a:spcAft>
+            </a:pPr>
+          </a:p>
+          <a:p>
+            <a:r>
+              <a:rPr sz="1800" b="1">
+                <a:solidFill>
+                  <a:srgbClr val="1A1A1A"/>
+                </a:solidFill>
+              </a:rPr>
+              <a:t>▸ The businessman was very rich.</a:t>
+            </a:r>
+          </a:p>
+          <a:p>
+            <a:pPr>
+              <a:spcAft>
+                <a:spcPts val="1000"/>
+              </a:spcAft>
+            </a:pPr>
+            <a:r>
+              <a:rPr sz="1500" i="1">
+                <a:solidFill>
+                  <a:srgbClr val="777777"/>
+                </a:solidFill>
+              </a:rPr>
+              <a:t>   O empresário era muito rico.</a:t>
+            </a:r>
+          </a:p>
+          <a:p>
+            <a:pPr>
+              <a:spcAft>
+                <a:spcPts val="1000"/>
+              </a:spcAft>
+            </a:pPr>
+          </a:p>
+          <a:p>
+            <a:r>
+              <a:rPr sz="1800" b="1">
+                <a:solidFill>
+                  <a:srgbClr val="1A1A1A"/>
+                </a:solidFill>
+              </a:rPr>
+              <a:t>▸ It's late, she was sick.</a:t>
+            </a:r>
+          </a:p>
+          <a:p>
+            <a:pPr>
+              <a:spcAft>
+                <a:spcPts val="1000"/>
+              </a:spcAft>
+            </a:pPr>
+            <a:r>
+              <a:rPr sz="1500" i="1">
+                <a:solidFill>
+                  <a:srgbClr val="777777"/>
+                </a:solidFill>
+              </a:rPr>
+              <a:t>   É tarde, ela estava doente.</a:t>
+            </a:r>
+          </a:p>
+        </p:txBody>
+      </p:sp>
+      <p:sp>
+        <p:nvSpPr>
+          <p:cNvPr id="5" name="TextBox 4"/>
+          <p:cNvSpPr txBox="1"/>
+          <p:nvPr/>
+        </p:nvSpPr>
+        <p:spPr>
+          <a:xfrm>
+            <a:off x="914400" y="6309360"/>
+            <a:ext cx="7772400" cy="457200"/>
+          </a:xfrm>
+          <a:prstGeom prst="rect">
+            <a:avLst/>
+          </a:prstGeom>
+          <a:noFill/>
+        </p:spPr>
+        <p:txBody>
+          <a:bodyPr wrap="none">
+            <a:spAutoFit/>
+          </a:bodyPr>
+          <a:lstStyle/>
+          <a:p>
+            <a:pPr algn="ctr"/>
+            <a:r>
+              <a:rPr sz="1200">
+                <a:solidFill>
+                  <a:srgbClr val="999999"/>
+                </a:solidFill>
+              </a:rPr>
+              <a:t>www.rawenglish.com.br</a:t>
+            </a:r>
+          </a:p>
+        </p:txBody>
+      </p:sp>
+    </p:spTree>
+  </p:cSld>
+  <p:clrMapOvr>
+    <a:masterClrMapping/>
+  </p:clrMapOvr>
+</p:sld>
+</file>
+
+<file path=ppt/slides/slide28.xml><?xml version="1.0" encoding="utf-8"?>
+<p:sld xmlns:a="http://schemas.openxmlformats.org/drawingml/2006/main" xmlns:p="http://schemas.openxmlformats.org/presentationml/2006/main" xmlns:r="http://schemas.openxmlformats.org/officeDocument/2006/relationships">
+  <p:cSld>
+    <p:spTree>
+      <p:nvGrpSpPr>
+        <p:cNvPr id="1" name=""/>
+        <p:cNvGrpSpPr/>
+        <p:nvPr/>
+      </p:nvGrpSpPr>
+      <p:grpSpPr/>
+      <p:sp>
+        <p:nvSpPr>
+          <p:cNvPr id="2" name="TextBox 1"/>
+          <p:cNvSpPr txBox="1"/>
+          <p:nvPr/>
+        </p:nvSpPr>
+        <p:spPr>
+          <a:xfrm>
+            <a:off x="914400" y="457200"/>
+            <a:ext cx="7772400" cy="731520"/>
+          </a:xfrm>
+          <a:prstGeom prst="rect">
+            <a:avLst/>
+          </a:prstGeom>
+          <a:noFill/>
+        </p:spPr>
+        <p:txBody>
+          <a:bodyPr wrap="none">
+            <a:spAutoFit/>
+          </a:bodyPr>
+          <a:lstStyle/>
+          <a:p>
+            <a:pPr algn="ctr"/>
+            <a:r>
+              <a:rPr sz="2800" b="1">
+                <a:solidFill>
+                  <a:srgbClr val="333333"/>
+                </a:solidFill>
+              </a:rPr>
+              <a:t>Lesson 3</a:t>
+            </a:r>
+          </a:p>
+        </p:txBody>
+      </p:sp>
+      <p:sp>
+        <p:nvSpPr>
+          <p:cNvPr id="3" name="TextBox 2"/>
+          <p:cNvSpPr txBox="1"/>
+          <p:nvPr/>
+        </p:nvSpPr>
+        <p:spPr>
+          <a:xfrm>
+            <a:off x="914400" y="1097280"/>
+            <a:ext cx="7772400" cy="548640"/>
+          </a:xfrm>
+          <a:prstGeom prst="rect">
+            <a:avLst/>
+          </a:prstGeom>
+          <a:noFill/>
+        </p:spPr>
+        <p:txBody>
+          <a:bodyPr wrap="none">
+            <a:spAutoFit/>
+          </a:bodyPr>
+          <a:lstStyle/>
+          <a:p>
+            <a:pPr algn="ctr"/>
+            <a:r>
+              <a:rPr sz="2400" b="1">
+                <a:solidFill>
+                  <a:srgbClr val="E86C00"/>
+                </a:solidFill>
+              </a:rPr>
+              <a:t>PRACTICE / PRATIQUE</a:t>
+            </a:r>
+          </a:p>
+        </p:txBody>
+      </p:sp>
+      <p:sp>
+        <p:nvSpPr>
+          <p:cNvPr id="4" name="TextBox 3"/>
+          <p:cNvSpPr txBox="1"/>
+          <p:nvPr/>
+        </p:nvSpPr>
+        <p:spPr>
+          <a:xfrm>
+            <a:off x="1097280" y="1645920"/>
+            <a:ext cx="9144000" cy="4114800"/>
+          </a:xfrm>
+          <a:prstGeom prst="rect">
+            <a:avLst/>
+          </a:prstGeom>
+          <a:noFill/>
+        </p:spPr>
+        <p:txBody>
+          <a:bodyPr wrap="square" anchor="t">
+            <a:spAutoFit/>
+          </a:bodyPr>
+          <a:lstStyle/>
+          <a:p>
+            <a:r>
+              <a:rPr sz="1800" b="1">
+                <a:solidFill>
+                  <a:srgbClr val="1A1A1A"/>
+                </a:solidFill>
+              </a:rPr>
+              <a:t>▸ I met a waiter at the hotel.</a:t>
+            </a:r>
+          </a:p>
+          <a:p>
+            <a:pPr>
+              <a:spcAft>
+                <a:spcPts val="1000"/>
+              </a:spcAft>
+            </a:pPr>
+            <a:r>
+              <a:rPr sz="1500" i="1">
+                <a:solidFill>
+                  <a:srgbClr val="777777"/>
+                </a:solidFill>
+              </a:rPr>
+              <a:t>   Eu conheci um garçom no hotel.</a:t>
+            </a:r>
+          </a:p>
+          <a:p>
+            <a:pPr>
+              <a:spcAft>
+                <a:spcPts val="1000"/>
+              </a:spcAft>
+            </a:pPr>
+          </a:p>
+          <a:p>
+            <a:r>
+              <a:rPr sz="1800" b="1">
+                <a:solidFill>
+                  <a:srgbClr val="1A1A1A"/>
+                </a:solidFill>
+              </a:rPr>
+              <a:t>▸ She spoke with the waitress.</a:t>
+            </a:r>
+          </a:p>
+          <a:p>
+            <a:pPr>
+              <a:spcAft>
+                <a:spcPts val="1000"/>
+              </a:spcAft>
+            </a:pPr>
+            <a:r>
+              <a:rPr sz="1500" i="1">
+                <a:solidFill>
+                  <a:srgbClr val="777777"/>
+                </a:solidFill>
+              </a:rPr>
+              <a:t>   Ela falou com a garçonete.</a:t>
+            </a:r>
+          </a:p>
+          <a:p>
+            <a:pPr>
+              <a:spcAft>
+                <a:spcPts val="1000"/>
+              </a:spcAft>
+            </a:pPr>
+          </a:p>
+          <a:p>
+            <a:r>
+              <a:rPr sz="1800" b="1">
+                <a:solidFill>
+                  <a:srgbClr val="1A1A1A"/>
+                </a:solidFill>
+              </a:rPr>
+              <a:t>▸ He helped me in a hurry.</a:t>
+            </a:r>
+          </a:p>
+          <a:p>
+            <a:pPr>
+              <a:spcAft>
+                <a:spcPts val="1000"/>
+              </a:spcAft>
+            </a:pPr>
+            <a:r>
+              <a:rPr sz="1500" i="1">
+                <a:solidFill>
+                  <a:srgbClr val="777777"/>
+                </a:solidFill>
+              </a:rPr>
+              <a:t>   Ele me ajudou com pressa.</a:t>
+            </a:r>
+          </a:p>
+          <a:p>
+            <a:pPr>
+              <a:spcAft>
+                <a:spcPts val="1000"/>
+              </a:spcAft>
+            </a:pPr>
+          </a:p>
+          <a:p>
+            <a:r>
+              <a:rPr sz="1800" b="1">
+                <a:solidFill>
+                  <a:srgbClr val="1A1A1A"/>
+                </a:solidFill>
+              </a:rPr>
+              <a:t>▸ I called you on time.</a:t>
+            </a:r>
+          </a:p>
+          <a:p>
+            <a:pPr>
+              <a:spcAft>
+                <a:spcPts val="1000"/>
+              </a:spcAft>
+            </a:pPr>
+            <a:r>
+              <a:rPr sz="1500" i="1">
+                <a:solidFill>
+                  <a:srgbClr val="777777"/>
+                </a:solidFill>
+              </a:rPr>
+              <a:t>   Eu te liguei na hora certa.</a:t>
+            </a:r>
+          </a:p>
+          <a:p>
+            <a:pPr>
+              <a:spcAft>
+                <a:spcPts val="1000"/>
+              </a:spcAft>
+            </a:pPr>
+          </a:p>
+          <a:p>
+            <a:r>
+              <a:rPr sz="1800" b="1">
+                <a:solidFill>
+                  <a:srgbClr val="1A1A1A"/>
+                </a:solidFill>
+              </a:rPr>
+              <a:t>▸ We ate steak, medium, with french fries.</a:t>
+            </a:r>
+          </a:p>
+          <a:p>
+            <a:pPr>
+              <a:spcAft>
+                <a:spcPts val="1000"/>
+              </a:spcAft>
+            </a:pPr>
+            <a:r>
+              <a:rPr sz="1500" i="1">
+                <a:solidFill>
+                  <a:srgbClr val="777777"/>
+                </a:solidFill>
+              </a:rPr>
+              <a:t>   Nós comemos bife, ao ponto, com batata frita.</a:t>
+            </a:r>
+          </a:p>
+          <a:p>
+            <a:pPr>
+              <a:spcAft>
+                <a:spcPts val="1000"/>
+              </a:spcAft>
+            </a:pPr>
+          </a:p>
+          <a:p>
+            <a:r>
+              <a:rPr sz="1800" b="1">
+                <a:solidFill>
+                  <a:srgbClr val="1A1A1A"/>
+                </a:solidFill>
+              </a:rPr>
+              <a:t>▸ They were hungry and thirsty.</a:t>
+            </a:r>
+          </a:p>
+          <a:p>
+            <a:pPr>
+              <a:spcAft>
+                <a:spcPts val="1000"/>
+              </a:spcAft>
+            </a:pPr>
+            <a:r>
+              <a:rPr sz="1500" i="1">
+                <a:solidFill>
+                  <a:srgbClr val="777777"/>
+                </a:solidFill>
+              </a:rPr>
+              <a:t>   Eles estavam com fome e com sede.</a:t>
+            </a:r>
+          </a:p>
+        </p:txBody>
+      </p:sp>
+      <p:sp>
+        <p:nvSpPr>
+          <p:cNvPr id="5" name="TextBox 4"/>
+          <p:cNvSpPr txBox="1"/>
+          <p:nvPr/>
+        </p:nvSpPr>
+        <p:spPr>
+          <a:xfrm>
+            <a:off x="914400" y="6309360"/>
+            <a:ext cx="7772400" cy="457200"/>
+          </a:xfrm>
+          <a:prstGeom prst="rect">
+            <a:avLst/>
+          </a:prstGeom>
+          <a:noFill/>
+        </p:spPr>
+        <p:txBody>
+          <a:bodyPr wrap="none">
+            <a:spAutoFit/>
+          </a:bodyPr>
+          <a:lstStyle/>
+          <a:p>
+            <a:pPr algn="ctr"/>
+            <a:r>
+              <a:rPr sz="1200">
+                <a:solidFill>
+                  <a:srgbClr val="999999"/>
+                </a:solidFill>
+              </a:rPr>
+              <a:t>www.rawenglish.com.br</a:t>
+            </a:r>
+          </a:p>
+        </p:txBody>
+      </p:sp>
+    </p:spTree>
+  </p:cSld>
+  <p:clrMapOvr>
+    <a:masterClrMapping/>
+  </p:clrMapOvr>
+</p:sld>
+</file>
+
+<file path=ppt/slides/slide29.xml><?xml version="1.0" encoding="utf-8"?>
+<p:sld xmlns:a="http://schemas.openxmlformats.org/drawingml/2006/main" xmlns:p="http://schemas.openxmlformats.org/presentationml/2006/main" xmlns:r="http://schemas.openxmlformats.org/officeDocument/2006/relationships">
+  <p:cSld>
+    <p:spTree>
+      <p:nvGrpSpPr>
+        <p:cNvPr id="1" name=""/>
+        <p:cNvGrpSpPr/>
+        <p:nvPr/>
+      </p:nvGrpSpPr>
+      <p:grpSpPr/>
+      <p:sp>
+        <p:nvSpPr>
+          <p:cNvPr id="2" name="TextBox 1"/>
+          <p:cNvSpPr txBox="1"/>
+          <p:nvPr/>
+        </p:nvSpPr>
+        <p:spPr>
+          <a:xfrm>
+            <a:off x="914400" y="457200"/>
+            <a:ext cx="7772400" cy="731520"/>
+          </a:xfrm>
+          <a:prstGeom prst="rect">
+            <a:avLst/>
+          </a:prstGeom>
+          <a:noFill/>
+        </p:spPr>
+        <p:txBody>
+          <a:bodyPr wrap="none">
+            <a:spAutoFit/>
+          </a:bodyPr>
+          <a:lstStyle/>
+          <a:p>
+            <a:pPr algn="ctr"/>
+            <a:r>
+              <a:rPr sz="2800" b="1">
+                <a:solidFill>
+                  <a:srgbClr val="333333"/>
+                </a:solidFill>
+              </a:rPr>
+              <a:t>Lesson 4</a:t>
+            </a:r>
+          </a:p>
+        </p:txBody>
+      </p:sp>
+      <p:sp>
+        <p:nvSpPr>
+          <p:cNvPr id="3" name="TextBox 2"/>
+          <p:cNvSpPr txBox="1"/>
+          <p:nvPr/>
+        </p:nvSpPr>
+        <p:spPr>
+          <a:xfrm>
+            <a:off x="914400" y="1097280"/>
+            <a:ext cx="7772400" cy="548640"/>
+          </a:xfrm>
+          <a:prstGeom prst="rect">
+            <a:avLst/>
+          </a:prstGeom>
+          <a:noFill/>
+        </p:spPr>
+        <p:txBody>
+          <a:bodyPr wrap="none">
+            <a:spAutoFit/>
+          </a:bodyPr>
+          <a:lstStyle/>
+          <a:p>
+            <a:pPr algn="ctr"/>
+            <a:r>
+              <a:rPr sz="2400" b="1">
+                <a:solidFill>
+                  <a:srgbClr val="E86C00"/>
+                </a:solidFill>
+              </a:rPr>
+              <a:t>PRACTICE / PRATIQUE</a:t>
+            </a:r>
+          </a:p>
+        </p:txBody>
+      </p:sp>
+      <p:sp>
+        <p:nvSpPr>
+          <p:cNvPr id="4" name="TextBox 3"/>
+          <p:cNvSpPr txBox="1"/>
+          <p:nvPr/>
+        </p:nvSpPr>
+        <p:spPr>
+          <a:xfrm>
+            <a:off x="1097280" y="1645920"/>
+            <a:ext cx="9144000" cy="4114800"/>
+          </a:xfrm>
+          <a:prstGeom prst="rect">
+            <a:avLst/>
+          </a:prstGeom>
+          <a:noFill/>
+        </p:spPr>
+        <p:txBody>
+          <a:bodyPr wrap="square" anchor="t">
+            <a:spAutoFit/>
+          </a:bodyPr>
+          <a:lstStyle/>
+          <a:p>
+            <a:r>
+              <a:rPr sz="1800" b="1">
+                <a:solidFill>
+                  <a:srgbClr val="1A1A1A"/>
+                </a:solidFill>
+              </a:rPr>
+              <a:t>▸ The children played with the key.</a:t>
+            </a:r>
+          </a:p>
+          <a:p>
+            <a:pPr>
+              <a:spcAft>
+                <a:spcPts val="1000"/>
+              </a:spcAft>
+            </a:pPr>
+            <a:r>
+              <a:rPr sz="1500" i="1">
+                <a:solidFill>
+                  <a:srgbClr val="777777"/>
+                </a:solidFill>
+              </a:rPr>
+              <a:t>   As crianças brincaram com a chave.</a:t>
+            </a:r>
+          </a:p>
+          <a:p>
+            <a:pPr>
+              <a:spcAft>
+                <a:spcPts val="1000"/>
+              </a:spcAft>
+            </a:pPr>
+          </a:p>
+          <a:p>
+            <a:r>
+              <a:rPr sz="1800" b="1">
+                <a:solidFill>
+                  <a:srgbClr val="1A1A1A"/>
+                </a:solidFill>
+              </a:rPr>
+              <a:t>▸ I bought a pie for my favorite mechanic.</a:t>
+            </a:r>
+          </a:p>
+          <a:p>
+            <a:pPr>
+              <a:spcAft>
+                <a:spcPts val="1000"/>
+              </a:spcAft>
+            </a:pPr>
+            <a:r>
+              <a:rPr sz="1500" i="1">
+                <a:solidFill>
+                  <a:srgbClr val="777777"/>
+                </a:solidFill>
+              </a:rPr>
+              <a:t>   Eu comprei uma torta pro meu mecânico favorito.</a:t>
+            </a:r>
+          </a:p>
+          <a:p>
+            <a:pPr>
+              <a:spcAft>
+                <a:spcPts val="1000"/>
+              </a:spcAft>
+            </a:pPr>
+          </a:p>
+          <a:p>
+            <a:r>
+              <a:rPr sz="1800" b="1">
+                <a:solidFill>
+                  <a:srgbClr val="1A1A1A"/>
+                </a:solidFill>
+              </a:rPr>
+              <a:t>▸ She closed the suitcase and the fridge.</a:t>
+            </a:r>
+          </a:p>
+          <a:p>
+            <a:pPr>
+              <a:spcAft>
+                <a:spcPts val="1000"/>
+              </a:spcAft>
+            </a:pPr>
+            <a:r>
+              <a:rPr sz="1500" i="1">
+                <a:solidFill>
+                  <a:srgbClr val="777777"/>
+                </a:solidFill>
+              </a:rPr>
+              <a:t>   Ela fechou a mala e a geladeira.</a:t>
+            </a:r>
+          </a:p>
+          <a:p>
+            <a:pPr>
+              <a:spcAft>
+                <a:spcPts val="1000"/>
+              </a:spcAft>
+            </a:pPr>
+          </a:p>
+          <a:p>
+            <a:r>
+              <a:rPr sz="1800" b="1">
+                <a:solidFill>
+                  <a:srgbClr val="1A1A1A"/>
+                </a:solidFill>
+              </a:rPr>
+              <a:t>▸ He opened the door behind the student.</a:t>
+            </a:r>
+          </a:p>
+          <a:p>
+            <a:pPr>
+              <a:spcAft>
+                <a:spcPts val="1000"/>
+              </a:spcAft>
+            </a:pPr>
+            <a:r>
+              <a:rPr sz="1500" i="1">
+                <a:solidFill>
+                  <a:srgbClr val="777777"/>
+                </a:solidFill>
+              </a:rPr>
+              <a:t>   Ele abriu a porta atrás do aluno.</a:t>
+            </a:r>
+          </a:p>
+          <a:p>
+            <a:pPr>
+              <a:spcAft>
+                <a:spcPts val="1000"/>
+              </a:spcAft>
+            </a:pPr>
+          </a:p>
+          <a:p>
+            <a:r>
+              <a:rPr sz="1800" b="1">
+                <a:solidFill>
+                  <a:srgbClr val="1A1A1A"/>
+                </a:solidFill>
+              </a:rPr>
+              <a:t>▸ We had fun after a while.</a:t>
+            </a:r>
+          </a:p>
+          <a:p>
+            <a:pPr>
+              <a:spcAft>
+                <a:spcPts val="1000"/>
+              </a:spcAft>
+            </a:pPr>
+            <a:r>
+              <a:rPr sz="1500" i="1">
+                <a:solidFill>
+                  <a:srgbClr val="777777"/>
+                </a:solidFill>
+              </a:rPr>
+              <a:t>   Nós nos divertimos depois de um tempo.</a:t>
+            </a:r>
+          </a:p>
+          <a:p>
+            <a:pPr>
+              <a:spcAft>
+                <a:spcPts val="1000"/>
+              </a:spcAft>
+            </a:pPr>
+          </a:p>
+          <a:p>
+            <a:r>
+              <a:rPr sz="1800" b="1">
+                <a:solidFill>
+                  <a:srgbClr val="1A1A1A"/>
+                </a:solidFill>
+              </a:rPr>
+              <a:t>▸ What's the matter? The bill was wrong.</a:t>
+            </a:r>
+          </a:p>
+          <a:p>
+            <a:pPr>
+              <a:spcAft>
+                <a:spcPts val="1000"/>
+              </a:spcAft>
+            </a:pPr>
+            <a:r>
+              <a:rPr sz="1500" i="1">
+                <a:solidFill>
+                  <a:srgbClr val="777777"/>
+                </a:solidFill>
+              </a:rPr>
+              <a:t>   Qual é o problema? A conta estava errada.</a:t>
+            </a:r>
+          </a:p>
+        </p:txBody>
+      </p:sp>
+      <p:sp>
+        <p:nvSpPr>
+          <p:cNvPr id="5" name="TextBox 4"/>
+          <p:cNvSpPr txBox="1"/>
+          <p:nvPr/>
+        </p:nvSpPr>
+        <p:spPr>
+          <a:xfrm>
+            <a:off x="914400" y="6309360"/>
+            <a:ext cx="7772400" cy="457200"/>
+          </a:xfrm>
+          <a:prstGeom prst="rect">
+            <a:avLst/>
+          </a:prstGeom>
+          <a:noFill/>
+        </p:spPr>
+        <p:txBody>
+          <a:bodyPr wrap="none">
+            <a:spAutoFit/>
+          </a:bodyPr>
+          <a:lstStyle/>
+          <a:p>
+            <a:pPr algn="ctr"/>
+            <a:r>
+              <a:rPr sz="1200">
+                <a:solidFill>
+                  <a:srgbClr val="999999"/>
+                </a:solidFill>
+              </a:rPr>
+              <a:t>www.rawenglish.com.br</a:t>
+            </a:r>
+          </a:p>
+        </p:txBody>
+      </p:sp>
+    </p:spTree>
+  </p:cSld>
+  <p:clrMapOvr>
+    <a:masterClrMapping/>
+  </p:clrMapOvr>
+</p:sld>
+</file>
+
 <file path=ppt/slides/slide3.xml><?xml version="1.0" encoding="utf-8"?>
 <p:sld xmlns:a="http://schemas.openxmlformats.org/drawingml/2006/main" xmlns:r="http://schemas.openxmlformats.org/officeDocument/2006/relationships" xmlns:p="http://schemas.openxmlformats.org/presentationml/2006/main">
   <p:cSld>
@@ -23362,6 +24686,2630 @@
         <p14:creationId xmlns:p14="http://schemas.microsoft.com/office/powerpoint/2010/main" val="1032441555"/>
       </p:ext>
     </p:extLst>
+  </p:cSld>
+  <p:clrMapOvr>
+    <a:masterClrMapping/>
+  </p:clrMapOvr>
+</p:sld>
+</file>
+
+<file path=ppt/slides/slide30.xml><?xml version="1.0" encoding="utf-8"?>
+<p:sld xmlns:a="http://schemas.openxmlformats.org/drawingml/2006/main" xmlns:p="http://schemas.openxmlformats.org/presentationml/2006/main" xmlns:r="http://schemas.openxmlformats.org/officeDocument/2006/relationships">
+  <p:cSld>
+    <p:spTree>
+      <p:nvGrpSpPr>
+        <p:cNvPr id="1" name=""/>
+        <p:cNvGrpSpPr/>
+        <p:nvPr/>
+      </p:nvGrpSpPr>
+      <p:grpSpPr/>
+      <p:sp>
+        <p:nvSpPr>
+          <p:cNvPr id="2" name="TextBox 1"/>
+          <p:cNvSpPr txBox="1"/>
+          <p:nvPr/>
+        </p:nvSpPr>
+        <p:spPr>
+          <a:xfrm>
+            <a:off x="914400" y="457200"/>
+            <a:ext cx="7772400" cy="731520"/>
+          </a:xfrm>
+          <a:prstGeom prst="rect">
+            <a:avLst/>
+          </a:prstGeom>
+          <a:noFill/>
+        </p:spPr>
+        <p:txBody>
+          <a:bodyPr wrap="none">
+            <a:spAutoFit/>
+          </a:bodyPr>
+          <a:lstStyle/>
+          <a:p>
+            <a:pPr algn="ctr"/>
+            <a:r>
+              <a:rPr sz="2800" b="1">
+                <a:solidFill>
+                  <a:srgbClr val="333333"/>
+                </a:solidFill>
+              </a:rPr>
+              <a:t>Lesson 5</a:t>
+            </a:r>
+          </a:p>
+        </p:txBody>
+      </p:sp>
+      <p:sp>
+        <p:nvSpPr>
+          <p:cNvPr id="3" name="TextBox 2"/>
+          <p:cNvSpPr txBox="1"/>
+          <p:nvPr/>
+        </p:nvSpPr>
+        <p:spPr>
+          <a:xfrm>
+            <a:off x="914400" y="1097280"/>
+            <a:ext cx="7772400" cy="548640"/>
+          </a:xfrm>
+          <a:prstGeom prst="rect">
+            <a:avLst/>
+          </a:prstGeom>
+          <a:noFill/>
+        </p:spPr>
+        <p:txBody>
+          <a:bodyPr wrap="none">
+            <a:spAutoFit/>
+          </a:bodyPr>
+          <a:lstStyle/>
+          <a:p>
+            <a:pPr algn="ctr"/>
+            <a:r>
+              <a:rPr sz="2400" b="1">
+                <a:solidFill>
+                  <a:srgbClr val="E86C00"/>
+                </a:solidFill>
+              </a:rPr>
+              <a:t>PRACTICE / PRATIQUE</a:t>
+            </a:r>
+          </a:p>
+        </p:txBody>
+      </p:sp>
+      <p:sp>
+        <p:nvSpPr>
+          <p:cNvPr id="4" name="TextBox 3"/>
+          <p:cNvSpPr txBox="1"/>
+          <p:nvPr/>
+        </p:nvSpPr>
+        <p:spPr>
+          <a:xfrm>
+            <a:off x="1097280" y="1645920"/>
+            <a:ext cx="9144000" cy="4114800"/>
+          </a:xfrm>
+          <a:prstGeom prst="rect">
+            <a:avLst/>
+          </a:prstGeom>
+          <a:noFill/>
+        </p:spPr>
+        <p:txBody>
+          <a:bodyPr wrap="square" anchor="t">
+            <a:spAutoFit/>
+          </a:bodyPr>
+          <a:lstStyle/>
+          <a:p>
+            <a:r>
+              <a:rPr sz="1800" b="1">
+                <a:solidFill>
+                  <a:srgbClr val="1A1A1A"/>
+                </a:solidFill>
+              </a:rPr>
+              <a:t>▸ I needed to travel but I was tired.</a:t>
+            </a:r>
+          </a:p>
+          <a:p>
+            <a:pPr>
+              <a:spcAft>
+                <a:spcPts val="1000"/>
+              </a:spcAft>
+            </a:pPr>
+            <a:r>
+              <a:rPr sz="1500" i="1">
+                <a:solidFill>
+                  <a:srgbClr val="777777"/>
+                </a:solidFill>
+              </a:rPr>
+              <a:t>   Eu precisei viajar mas eu estava cansado.</a:t>
+            </a:r>
+          </a:p>
+          <a:p>
+            <a:pPr>
+              <a:spcAft>
+                <a:spcPts val="1000"/>
+              </a:spcAft>
+            </a:pPr>
+          </a:p>
+          <a:p>
+            <a:r>
+              <a:rPr sz="1800" b="1">
+                <a:solidFill>
+                  <a:srgbClr val="1A1A1A"/>
+                </a:solidFill>
+              </a:rPr>
+              <a:t>▸ She met the police officer yesterday.</a:t>
+            </a:r>
+          </a:p>
+          <a:p>
+            <a:pPr>
+              <a:spcAft>
+                <a:spcPts val="1000"/>
+              </a:spcAft>
+            </a:pPr>
+            <a:r>
+              <a:rPr sz="1500" i="1">
+                <a:solidFill>
+                  <a:srgbClr val="777777"/>
+                </a:solidFill>
+              </a:rPr>
+              <a:t>   Ela conheceu o policial ontem.</a:t>
+            </a:r>
+          </a:p>
+          <a:p>
+            <a:pPr>
+              <a:spcAft>
+                <a:spcPts val="1000"/>
+              </a:spcAft>
+            </a:pPr>
+          </a:p>
+          <a:p>
+            <a:r>
+              <a:rPr sz="1800" b="1">
+                <a:solidFill>
+                  <a:srgbClr val="1A1A1A"/>
+                </a:solidFill>
+              </a:rPr>
+              <a:t>▸ He started and finished on time.</a:t>
+            </a:r>
+          </a:p>
+          <a:p>
+            <a:pPr>
+              <a:spcAft>
+                <a:spcPts val="1000"/>
+              </a:spcAft>
+            </a:pPr>
+            <a:r>
+              <a:rPr sz="1500" i="1">
+                <a:solidFill>
+                  <a:srgbClr val="777777"/>
+                </a:solidFill>
+              </a:rPr>
+              <a:t>   Ele começou e terminou na hora.</a:t>
+            </a:r>
+          </a:p>
+          <a:p>
+            <a:pPr>
+              <a:spcAft>
+                <a:spcPts val="1000"/>
+              </a:spcAft>
+            </a:pPr>
+          </a:p>
+          <a:p>
+            <a:r>
+              <a:rPr sz="1800" b="1">
+                <a:solidFill>
+                  <a:srgbClr val="1A1A1A"/>
+                </a:solidFill>
+              </a:rPr>
+              <a:t>▸ We called and they helped us.</a:t>
+            </a:r>
+          </a:p>
+          <a:p>
+            <a:pPr>
+              <a:spcAft>
+                <a:spcPts val="1000"/>
+              </a:spcAft>
+            </a:pPr>
+            <a:r>
+              <a:rPr sz="1500" i="1">
+                <a:solidFill>
+                  <a:srgbClr val="777777"/>
+                </a:solidFill>
+              </a:rPr>
+              <a:t>   Nós ligamos e eles nos ajudaram.</a:t>
+            </a:r>
+          </a:p>
+          <a:p>
+            <a:pPr>
+              <a:spcAft>
+                <a:spcPts val="1000"/>
+              </a:spcAft>
+            </a:pPr>
+          </a:p>
+          <a:p>
+            <a:r>
+              <a:rPr sz="1800" b="1">
+                <a:solidFill>
+                  <a:srgbClr val="1A1A1A"/>
+                </a:solidFill>
+              </a:rPr>
+              <a:t>▸ I bought a boat and sold the old car.</a:t>
+            </a:r>
+          </a:p>
+          <a:p>
+            <a:pPr>
+              <a:spcAft>
+                <a:spcPts val="1000"/>
+              </a:spcAft>
+            </a:pPr>
+            <a:r>
+              <a:rPr sz="1500" i="1">
+                <a:solidFill>
+                  <a:srgbClr val="777777"/>
+                </a:solidFill>
+              </a:rPr>
+              <a:t>   Eu comprei um barco e vendi o carro velho.</a:t>
+            </a:r>
+          </a:p>
+          <a:p>
+            <a:pPr>
+              <a:spcAft>
+                <a:spcPts val="1000"/>
+              </a:spcAft>
+            </a:pPr>
+          </a:p>
+          <a:p>
+            <a:r>
+              <a:rPr sz="1800" b="1">
+                <a:solidFill>
+                  <a:srgbClr val="1A1A1A"/>
+                </a:solidFill>
+              </a:rPr>
+              <a:t>▸ Congratulations! You spoke very well.</a:t>
+            </a:r>
+          </a:p>
+          <a:p>
+            <a:pPr>
+              <a:spcAft>
+                <a:spcPts val="1000"/>
+              </a:spcAft>
+            </a:pPr>
+            <a:r>
+              <a:rPr sz="1500" i="1">
+                <a:solidFill>
+                  <a:srgbClr val="777777"/>
+                </a:solidFill>
+              </a:rPr>
+              <a:t>   Parabéns! Você falou muito bem.</a:t>
+            </a:r>
+          </a:p>
+        </p:txBody>
+      </p:sp>
+      <p:sp>
+        <p:nvSpPr>
+          <p:cNvPr id="5" name="TextBox 4"/>
+          <p:cNvSpPr txBox="1"/>
+          <p:nvPr/>
+        </p:nvSpPr>
+        <p:spPr>
+          <a:xfrm>
+            <a:off x="914400" y="6309360"/>
+            <a:ext cx="7772400" cy="457200"/>
+          </a:xfrm>
+          <a:prstGeom prst="rect">
+            <a:avLst/>
+          </a:prstGeom>
+          <a:noFill/>
+        </p:spPr>
+        <p:txBody>
+          <a:bodyPr wrap="none">
+            <a:spAutoFit/>
+          </a:bodyPr>
+          <a:lstStyle/>
+          <a:p>
+            <a:pPr algn="ctr"/>
+            <a:r>
+              <a:rPr sz="1200">
+                <a:solidFill>
+                  <a:srgbClr val="999999"/>
+                </a:solidFill>
+              </a:rPr>
+              <a:t>www.rawenglish.com.br</a:t>
+            </a:r>
+          </a:p>
+        </p:txBody>
+      </p:sp>
+    </p:spTree>
+  </p:cSld>
+  <p:clrMapOvr>
+    <a:masterClrMapping/>
+  </p:clrMapOvr>
+</p:sld>
+</file>
+
+<file path=ppt/slides/slide31.xml><?xml version="1.0" encoding="utf-8"?>
+<p:sld xmlns:a="http://schemas.openxmlformats.org/drawingml/2006/main" xmlns:p="http://schemas.openxmlformats.org/presentationml/2006/main" xmlns:r="http://schemas.openxmlformats.org/officeDocument/2006/relationships">
+  <p:cSld>
+    <p:spTree>
+      <p:nvGrpSpPr>
+        <p:cNvPr id="1" name=""/>
+        <p:cNvGrpSpPr/>
+        <p:nvPr/>
+      </p:nvGrpSpPr>
+      <p:grpSpPr/>
+      <p:sp>
+        <p:nvSpPr>
+          <p:cNvPr id="2" name="TextBox 1"/>
+          <p:cNvSpPr txBox="1"/>
+          <p:nvPr/>
+        </p:nvSpPr>
+        <p:spPr>
+          <a:xfrm>
+            <a:off x="914400" y="457200"/>
+            <a:ext cx="7772400" cy="731520"/>
+          </a:xfrm>
+          <a:prstGeom prst="rect">
+            <a:avLst/>
+          </a:prstGeom>
+          <a:noFill/>
+        </p:spPr>
+        <p:txBody>
+          <a:bodyPr wrap="none">
+            <a:spAutoFit/>
+          </a:bodyPr>
+          <a:lstStyle/>
+          <a:p>
+            <a:pPr algn="ctr"/>
+            <a:r>
+              <a:rPr sz="2800" b="1">
+                <a:solidFill>
+                  <a:srgbClr val="333333"/>
+                </a:solidFill>
+              </a:rPr>
+              <a:t>Lesson 6</a:t>
+            </a:r>
+          </a:p>
+        </p:txBody>
+      </p:sp>
+      <p:sp>
+        <p:nvSpPr>
+          <p:cNvPr id="3" name="TextBox 2"/>
+          <p:cNvSpPr txBox="1"/>
+          <p:nvPr/>
+        </p:nvSpPr>
+        <p:spPr>
+          <a:xfrm>
+            <a:off x="914400" y="1097280"/>
+            <a:ext cx="7772400" cy="548640"/>
+          </a:xfrm>
+          <a:prstGeom prst="rect">
+            <a:avLst/>
+          </a:prstGeom>
+          <a:noFill/>
+        </p:spPr>
+        <p:txBody>
+          <a:bodyPr wrap="none">
+            <a:spAutoFit/>
+          </a:bodyPr>
+          <a:lstStyle/>
+          <a:p>
+            <a:pPr algn="ctr"/>
+            <a:r>
+              <a:rPr sz="2400" b="1">
+                <a:solidFill>
+                  <a:srgbClr val="E86C00"/>
+                </a:solidFill>
+              </a:rPr>
+              <a:t>PRACTICE / PRATIQUE</a:t>
+            </a:r>
+          </a:p>
+        </p:txBody>
+      </p:sp>
+      <p:sp>
+        <p:nvSpPr>
+          <p:cNvPr id="4" name="TextBox 3"/>
+          <p:cNvSpPr txBox="1"/>
+          <p:nvPr/>
+        </p:nvSpPr>
+        <p:spPr>
+          <a:xfrm>
+            <a:off x="1097280" y="1645920"/>
+            <a:ext cx="9144000" cy="4114800"/>
+          </a:xfrm>
+          <a:prstGeom prst="rect">
+            <a:avLst/>
+          </a:prstGeom>
+          <a:noFill/>
+        </p:spPr>
+        <p:txBody>
+          <a:bodyPr wrap="square" anchor="t">
+            <a:spAutoFit/>
+          </a:bodyPr>
+          <a:lstStyle/>
+          <a:p>
+            <a:r>
+              <a:rPr sz="1800" b="1">
+                <a:solidFill>
+                  <a:srgbClr val="1A1A1A"/>
+                </a:solidFill>
+              </a:rPr>
+              <a:t>▸ I thought about my grandparents.</a:t>
+            </a:r>
+          </a:p>
+          <a:p>
+            <a:pPr>
+              <a:spcAft>
+                <a:spcPts val="1000"/>
+              </a:spcAft>
+            </a:pPr>
+            <a:r>
+              <a:rPr sz="1500" i="1">
+                <a:solidFill>
+                  <a:srgbClr val="777777"/>
+                </a:solidFill>
+              </a:rPr>
+              <a:t>   Eu pensei nos meus avós.</a:t>
+            </a:r>
+          </a:p>
+          <a:p>
+            <a:pPr>
+              <a:spcAft>
+                <a:spcPts val="1000"/>
+              </a:spcAft>
+            </a:pPr>
+          </a:p>
+          <a:p>
+            <a:r>
+              <a:rPr sz="1800" b="1">
+                <a:solidFill>
+                  <a:srgbClr val="1A1A1A"/>
+                </a:solidFill>
+              </a:rPr>
+              <a:t>▸ She cooked vegetables and soup.</a:t>
+            </a:r>
+          </a:p>
+          <a:p>
+            <a:pPr>
+              <a:spcAft>
+                <a:spcPts val="1000"/>
+              </a:spcAft>
+            </a:pPr>
+            <a:r>
+              <a:rPr sz="1500" i="1">
+                <a:solidFill>
+                  <a:srgbClr val="777777"/>
+                </a:solidFill>
+              </a:rPr>
+              <a:t>   Ela cozinhou legumes e sopa.</a:t>
+            </a:r>
+          </a:p>
+          <a:p>
+            <a:pPr>
+              <a:spcAft>
+                <a:spcPts val="1000"/>
+              </a:spcAft>
+            </a:pPr>
+          </a:p>
+          <a:p>
+            <a:r>
+              <a:rPr sz="1800" b="1">
+                <a:solidFill>
+                  <a:srgbClr val="1A1A1A"/>
+                </a:solidFill>
+              </a:rPr>
+              <a:t>▸ He sat inside the store.</a:t>
+            </a:r>
+          </a:p>
+          <a:p>
+            <a:pPr>
+              <a:spcAft>
+                <a:spcPts val="1000"/>
+              </a:spcAft>
+            </a:pPr>
+            <a:r>
+              <a:rPr sz="1500" i="1">
+                <a:solidFill>
+                  <a:srgbClr val="777777"/>
+                </a:solidFill>
+              </a:rPr>
+              <a:t>   Ele sentou dentro da loja.</a:t>
+            </a:r>
+          </a:p>
+          <a:p>
+            <a:pPr>
+              <a:spcAft>
+                <a:spcPts val="1000"/>
+              </a:spcAft>
+            </a:pPr>
+          </a:p>
+          <a:p>
+            <a:r>
+              <a:rPr sz="1800" b="1">
+                <a:solidFill>
+                  <a:srgbClr val="1A1A1A"/>
+                </a:solidFill>
+              </a:rPr>
+              <a:t>▸ We went outside for a coffee break.</a:t>
+            </a:r>
+          </a:p>
+          <a:p>
+            <a:pPr>
+              <a:spcAft>
+                <a:spcPts val="1000"/>
+              </a:spcAft>
+            </a:pPr>
+            <a:r>
+              <a:rPr sz="1500" i="1">
+                <a:solidFill>
+                  <a:srgbClr val="777777"/>
+                </a:solidFill>
+              </a:rPr>
+              <a:t>   Nós fomos lá fora para um intervalo.</a:t>
+            </a:r>
+          </a:p>
+          <a:p>
+            <a:pPr>
+              <a:spcAft>
+                <a:spcPts val="1000"/>
+              </a:spcAft>
+            </a:pPr>
+          </a:p>
+          <a:p>
+            <a:r>
+              <a:rPr sz="1800" b="1">
+                <a:solidFill>
+                  <a:srgbClr val="1A1A1A"/>
+                </a:solidFill>
+              </a:rPr>
+              <a:t>▸ Let's go! Come on!</a:t>
+            </a:r>
+          </a:p>
+          <a:p>
+            <a:pPr>
+              <a:spcAft>
+                <a:spcPts val="1000"/>
+              </a:spcAft>
+            </a:pPr>
+            <a:r>
+              <a:rPr sz="1500" i="1">
+                <a:solidFill>
+                  <a:srgbClr val="777777"/>
+                </a:solidFill>
+              </a:rPr>
+              <a:t>   Vamos! Vem!</a:t>
+            </a:r>
+          </a:p>
+          <a:p>
+            <a:pPr>
+              <a:spcAft>
+                <a:spcPts val="1000"/>
+              </a:spcAft>
+            </a:pPr>
+          </a:p>
+          <a:p>
+            <a:r>
+              <a:rPr sz="1800" b="1">
+                <a:solidFill>
+                  <a:srgbClr val="1A1A1A"/>
+                </a:solidFill>
+              </a:rPr>
+              <a:t>▸ Whatever, the experience was free.</a:t>
+            </a:r>
+          </a:p>
+          <a:p>
+            <a:pPr>
+              <a:spcAft>
+                <a:spcPts val="1000"/>
+              </a:spcAft>
+            </a:pPr>
+            <a:r>
+              <a:rPr sz="1500" i="1">
+                <a:solidFill>
+                  <a:srgbClr val="777777"/>
+                </a:solidFill>
+              </a:rPr>
+              <a:t>   Tanto faz, a experiência foi grátis.</a:t>
+            </a:r>
+          </a:p>
+        </p:txBody>
+      </p:sp>
+      <p:sp>
+        <p:nvSpPr>
+          <p:cNvPr id="5" name="TextBox 4"/>
+          <p:cNvSpPr txBox="1"/>
+          <p:nvPr/>
+        </p:nvSpPr>
+        <p:spPr>
+          <a:xfrm>
+            <a:off x="914400" y="6309360"/>
+            <a:ext cx="7772400" cy="457200"/>
+          </a:xfrm>
+          <a:prstGeom prst="rect">
+            <a:avLst/>
+          </a:prstGeom>
+          <a:noFill/>
+        </p:spPr>
+        <p:txBody>
+          <a:bodyPr wrap="none">
+            <a:spAutoFit/>
+          </a:bodyPr>
+          <a:lstStyle/>
+          <a:p>
+            <a:pPr algn="ctr"/>
+            <a:r>
+              <a:rPr sz="1200">
+                <a:solidFill>
+                  <a:srgbClr val="999999"/>
+                </a:solidFill>
+              </a:rPr>
+              <a:t>www.rawenglish.com.br</a:t>
+            </a:r>
+          </a:p>
+        </p:txBody>
+      </p:sp>
+    </p:spTree>
+  </p:cSld>
+  <p:clrMapOvr>
+    <a:masterClrMapping/>
+  </p:clrMapOvr>
+</p:sld>
+</file>
+
+<file path=ppt/slides/slide32.xml><?xml version="1.0" encoding="utf-8"?>
+<p:sld xmlns:a="http://schemas.openxmlformats.org/drawingml/2006/main" xmlns:p="http://schemas.openxmlformats.org/presentationml/2006/main" xmlns:r="http://schemas.openxmlformats.org/officeDocument/2006/relationships">
+  <p:cSld>
+    <p:spTree>
+      <p:nvGrpSpPr>
+        <p:cNvPr id="1" name=""/>
+        <p:cNvGrpSpPr/>
+        <p:nvPr/>
+      </p:nvGrpSpPr>
+      <p:grpSpPr/>
+      <p:sp>
+        <p:nvSpPr>
+          <p:cNvPr id="2" name="TextBox 1"/>
+          <p:cNvSpPr txBox="1"/>
+          <p:nvPr/>
+        </p:nvSpPr>
+        <p:spPr>
+          <a:xfrm>
+            <a:off x="914400" y="457200"/>
+            <a:ext cx="7772400" cy="731520"/>
+          </a:xfrm>
+          <a:prstGeom prst="rect">
+            <a:avLst/>
+          </a:prstGeom>
+          <a:noFill/>
+        </p:spPr>
+        <p:txBody>
+          <a:bodyPr wrap="none">
+            <a:spAutoFit/>
+          </a:bodyPr>
+          <a:lstStyle/>
+          <a:p>
+            <a:pPr algn="ctr"/>
+            <a:r>
+              <a:rPr sz="2800" b="1">
+                <a:solidFill>
+                  <a:srgbClr val="333333"/>
+                </a:solidFill>
+              </a:rPr>
+              <a:t>Lesson 7</a:t>
+            </a:r>
+          </a:p>
+        </p:txBody>
+      </p:sp>
+      <p:sp>
+        <p:nvSpPr>
+          <p:cNvPr id="3" name="TextBox 2"/>
+          <p:cNvSpPr txBox="1"/>
+          <p:nvPr/>
+        </p:nvSpPr>
+        <p:spPr>
+          <a:xfrm>
+            <a:off x="914400" y="1097280"/>
+            <a:ext cx="7772400" cy="548640"/>
+          </a:xfrm>
+          <a:prstGeom prst="rect">
+            <a:avLst/>
+          </a:prstGeom>
+          <a:noFill/>
+        </p:spPr>
+        <p:txBody>
+          <a:bodyPr wrap="none">
+            <a:spAutoFit/>
+          </a:bodyPr>
+          <a:lstStyle/>
+          <a:p>
+            <a:pPr algn="ctr"/>
+            <a:r>
+              <a:rPr sz="2400" b="1">
+                <a:solidFill>
+                  <a:srgbClr val="E86C00"/>
+                </a:solidFill>
+              </a:rPr>
+              <a:t>PRACTICE / PRATIQUE</a:t>
+            </a:r>
+          </a:p>
+        </p:txBody>
+      </p:sp>
+      <p:sp>
+        <p:nvSpPr>
+          <p:cNvPr id="4" name="TextBox 3"/>
+          <p:cNvSpPr txBox="1"/>
+          <p:nvPr/>
+        </p:nvSpPr>
+        <p:spPr>
+          <a:xfrm>
+            <a:off x="1097280" y="1645920"/>
+            <a:ext cx="9144000" cy="4114800"/>
+          </a:xfrm>
+          <a:prstGeom prst="rect">
+            <a:avLst/>
+          </a:prstGeom>
+          <a:noFill/>
+        </p:spPr>
+        <p:txBody>
+          <a:bodyPr wrap="square" anchor="t">
+            <a:spAutoFit/>
+          </a:bodyPr>
+          <a:lstStyle/>
+          <a:p>
+            <a:r>
+              <a:rPr sz="1800" b="1">
+                <a:solidFill>
+                  <a:srgbClr val="1A1A1A"/>
+                </a:solidFill>
+              </a:rPr>
+              <a:t>▸ I asked about the course schedule.</a:t>
+            </a:r>
+          </a:p>
+          <a:p>
+            <a:pPr>
+              <a:spcAft>
+                <a:spcPts val="1000"/>
+              </a:spcAft>
+            </a:pPr>
+            <a:r>
+              <a:rPr sz="1500" i="1">
+                <a:solidFill>
+                  <a:srgbClr val="777777"/>
+                </a:solidFill>
+              </a:rPr>
+              <a:t>   Eu perguntei sobre o horário do curso.</a:t>
+            </a:r>
+          </a:p>
+          <a:p>
+            <a:pPr>
+              <a:spcAft>
+                <a:spcPts val="1000"/>
+              </a:spcAft>
+            </a:pPr>
+          </a:p>
+          <a:p>
+            <a:r>
+              <a:rPr sz="1800" b="1">
+                <a:solidFill>
+                  <a:srgbClr val="1A1A1A"/>
+                </a:solidFill>
+              </a:rPr>
+              <a:t>▸ She answered the test at college.</a:t>
+            </a:r>
+          </a:p>
+          <a:p>
+            <a:pPr>
+              <a:spcAft>
+                <a:spcPts val="1000"/>
+              </a:spcAft>
+            </a:pPr>
+            <a:r>
+              <a:rPr sz="1500" i="1">
+                <a:solidFill>
+                  <a:srgbClr val="777777"/>
+                </a:solidFill>
+              </a:rPr>
+              <a:t>   Ela respondeu a prova na faculdade.</a:t>
+            </a:r>
+          </a:p>
+          <a:p>
+            <a:pPr>
+              <a:spcAft>
+                <a:spcPts val="1000"/>
+              </a:spcAft>
+            </a:pPr>
+          </a:p>
+          <a:p>
+            <a:r>
+              <a:rPr sz="1800" b="1">
+                <a:solidFill>
+                  <a:srgbClr val="1A1A1A"/>
+                </a:solidFill>
+              </a:rPr>
+              <a:t>▸ There is a pencil and an eraser on the desk.</a:t>
+            </a:r>
+          </a:p>
+          <a:p>
+            <a:pPr>
+              <a:spcAft>
+                <a:spcPts val="1000"/>
+              </a:spcAft>
+            </a:pPr>
+            <a:r>
+              <a:rPr sz="1500" i="1">
+                <a:solidFill>
+                  <a:srgbClr val="777777"/>
+                </a:solidFill>
+              </a:rPr>
+              <a:t>   Tem um lápis e uma borracha na mesa.</a:t>
+            </a:r>
+          </a:p>
+          <a:p>
+            <a:pPr>
+              <a:spcAft>
+                <a:spcPts val="1000"/>
+              </a:spcAft>
+            </a:pPr>
+          </a:p>
+          <a:p>
+            <a:r>
+              <a:rPr sz="1800" b="1">
+                <a:solidFill>
+                  <a:srgbClr val="1A1A1A"/>
+                </a:solidFill>
+              </a:rPr>
+              <a:t>▸ There are notebooks in the folder.</a:t>
+            </a:r>
+          </a:p>
+          <a:p>
+            <a:pPr>
+              <a:spcAft>
+                <a:spcPts val="1000"/>
+              </a:spcAft>
+            </a:pPr>
+            <a:r>
+              <a:rPr sz="1500" i="1">
+                <a:solidFill>
+                  <a:srgbClr val="777777"/>
+                </a:solidFill>
+              </a:rPr>
+              <a:t>   Tem cadernos na pasta.</a:t>
+            </a:r>
+          </a:p>
+          <a:p>
+            <a:pPr>
+              <a:spcAft>
+                <a:spcPts val="1000"/>
+              </a:spcAft>
+            </a:pPr>
+          </a:p>
+          <a:p>
+            <a:r>
+              <a:rPr sz="1800" b="1">
+                <a:solidFill>
+                  <a:srgbClr val="1A1A1A"/>
+                </a:solidFill>
+              </a:rPr>
+              <a:t>▸ Unfortunately, I talked too much.</a:t>
+            </a:r>
+          </a:p>
+          <a:p>
+            <a:pPr>
+              <a:spcAft>
+                <a:spcPts val="1000"/>
+              </a:spcAft>
+            </a:pPr>
+            <a:r>
+              <a:rPr sz="1500" i="1">
+                <a:solidFill>
+                  <a:srgbClr val="777777"/>
+                </a:solidFill>
+              </a:rPr>
+              <a:t>   Infelizmente, eu falei demais.</a:t>
+            </a:r>
+          </a:p>
+          <a:p>
+            <a:pPr>
+              <a:spcAft>
+                <a:spcPts val="1000"/>
+              </a:spcAft>
+            </a:pPr>
+          </a:p>
+          <a:p>
+            <a:r>
+              <a:rPr sz="1800" b="1">
+                <a:solidFill>
+                  <a:srgbClr val="1A1A1A"/>
+                </a:solidFill>
+              </a:rPr>
+              <a:t>▸ The grade was fortunately good.</a:t>
+            </a:r>
+          </a:p>
+          <a:p>
+            <a:pPr>
+              <a:spcAft>
+                <a:spcPts val="1000"/>
+              </a:spcAft>
+            </a:pPr>
+            <a:r>
+              <a:rPr sz="1500" i="1">
+                <a:solidFill>
+                  <a:srgbClr val="777777"/>
+                </a:solidFill>
+              </a:rPr>
+              <a:t>   A nota foi felizmente boa.</a:t>
+            </a:r>
+          </a:p>
+        </p:txBody>
+      </p:sp>
+      <p:sp>
+        <p:nvSpPr>
+          <p:cNvPr id="5" name="TextBox 4"/>
+          <p:cNvSpPr txBox="1"/>
+          <p:nvPr/>
+        </p:nvSpPr>
+        <p:spPr>
+          <a:xfrm>
+            <a:off x="914400" y="6309360"/>
+            <a:ext cx="7772400" cy="457200"/>
+          </a:xfrm>
+          <a:prstGeom prst="rect">
+            <a:avLst/>
+          </a:prstGeom>
+          <a:noFill/>
+        </p:spPr>
+        <p:txBody>
+          <a:bodyPr wrap="none">
+            <a:spAutoFit/>
+          </a:bodyPr>
+          <a:lstStyle/>
+          <a:p>
+            <a:pPr algn="ctr"/>
+            <a:r>
+              <a:rPr sz="1200">
+                <a:solidFill>
+                  <a:srgbClr val="999999"/>
+                </a:solidFill>
+              </a:rPr>
+              <a:t>www.rawenglish.com.br</a:t>
+            </a:r>
+          </a:p>
+        </p:txBody>
+      </p:sp>
+    </p:spTree>
+  </p:cSld>
+  <p:clrMapOvr>
+    <a:masterClrMapping/>
+  </p:clrMapOvr>
+</p:sld>
+</file>
+
+<file path=ppt/slides/slide33.xml><?xml version="1.0" encoding="utf-8"?>
+<p:sld xmlns:a="http://schemas.openxmlformats.org/drawingml/2006/main" xmlns:p="http://schemas.openxmlformats.org/presentationml/2006/main" xmlns:r="http://schemas.openxmlformats.org/officeDocument/2006/relationships">
+  <p:cSld>
+    <p:spTree>
+      <p:nvGrpSpPr>
+        <p:cNvPr id="1" name=""/>
+        <p:cNvGrpSpPr/>
+        <p:nvPr/>
+      </p:nvGrpSpPr>
+      <p:grpSpPr/>
+      <p:sp>
+        <p:nvSpPr>
+          <p:cNvPr id="2" name="TextBox 1"/>
+          <p:cNvSpPr txBox="1"/>
+          <p:nvPr/>
+        </p:nvSpPr>
+        <p:spPr>
+          <a:xfrm>
+            <a:off x="914400" y="457200"/>
+            <a:ext cx="7772400" cy="731520"/>
+          </a:xfrm>
+          <a:prstGeom prst="rect">
+            <a:avLst/>
+          </a:prstGeom>
+          <a:noFill/>
+        </p:spPr>
+        <p:txBody>
+          <a:bodyPr wrap="none">
+            <a:spAutoFit/>
+          </a:bodyPr>
+          <a:lstStyle/>
+          <a:p>
+            <a:pPr algn="ctr"/>
+            <a:r>
+              <a:rPr sz="2800" b="1">
+                <a:solidFill>
+                  <a:srgbClr val="333333"/>
+                </a:solidFill>
+              </a:rPr>
+              <a:t>Lesson 8</a:t>
+            </a:r>
+          </a:p>
+        </p:txBody>
+      </p:sp>
+      <p:sp>
+        <p:nvSpPr>
+          <p:cNvPr id="3" name="TextBox 2"/>
+          <p:cNvSpPr txBox="1"/>
+          <p:nvPr/>
+        </p:nvSpPr>
+        <p:spPr>
+          <a:xfrm>
+            <a:off x="914400" y="1097280"/>
+            <a:ext cx="7772400" cy="548640"/>
+          </a:xfrm>
+          <a:prstGeom prst="rect">
+            <a:avLst/>
+          </a:prstGeom>
+          <a:noFill/>
+        </p:spPr>
+        <p:txBody>
+          <a:bodyPr wrap="none">
+            <a:spAutoFit/>
+          </a:bodyPr>
+          <a:lstStyle/>
+          <a:p>
+            <a:pPr algn="ctr"/>
+            <a:r>
+              <a:rPr sz="2400" b="1">
+                <a:solidFill>
+                  <a:srgbClr val="E86C00"/>
+                </a:solidFill>
+              </a:rPr>
+              <a:t>PRACTICE / PRATIQUE</a:t>
+            </a:r>
+          </a:p>
+        </p:txBody>
+      </p:sp>
+      <p:sp>
+        <p:nvSpPr>
+          <p:cNvPr id="4" name="TextBox 3"/>
+          <p:cNvSpPr txBox="1"/>
+          <p:nvPr/>
+        </p:nvSpPr>
+        <p:spPr>
+          <a:xfrm>
+            <a:off x="1097280" y="1645920"/>
+            <a:ext cx="9144000" cy="4114800"/>
+          </a:xfrm>
+          <a:prstGeom prst="rect">
+            <a:avLst/>
+          </a:prstGeom>
+          <a:noFill/>
+        </p:spPr>
+        <p:txBody>
+          <a:bodyPr wrap="square" anchor="t">
+            <a:spAutoFit/>
+          </a:bodyPr>
+          <a:lstStyle/>
+          <a:p>
+            <a:r>
+              <a:rPr sz="1800" b="1">
+                <a:solidFill>
+                  <a:srgbClr val="1A1A1A"/>
+                </a:solidFill>
+              </a:rPr>
+              <a:t>▸ I left the building with the nurse.</a:t>
+            </a:r>
+          </a:p>
+          <a:p>
+            <a:pPr>
+              <a:spcAft>
+                <a:spcPts val="1000"/>
+              </a:spcAft>
+            </a:pPr>
+            <a:r>
+              <a:rPr sz="1500" i="1">
+                <a:solidFill>
+                  <a:srgbClr val="777777"/>
+                </a:solidFill>
+              </a:rPr>
+              <a:t>   Eu saí do prédio com a enfermeira.</a:t>
+            </a:r>
+          </a:p>
+          <a:p>
+            <a:pPr>
+              <a:spcAft>
+                <a:spcPts val="1000"/>
+              </a:spcAft>
+            </a:pPr>
+          </a:p>
+          <a:p>
+            <a:r>
+              <a:rPr sz="1800" b="1">
+                <a:solidFill>
+                  <a:srgbClr val="1A1A1A"/>
+                </a:solidFill>
+              </a:rPr>
+              <a:t>▸ She watched the movie at the theater.</a:t>
+            </a:r>
+          </a:p>
+          <a:p>
+            <a:pPr>
+              <a:spcAft>
+                <a:spcPts val="1000"/>
+              </a:spcAft>
+            </a:pPr>
+            <a:r>
+              <a:rPr sz="1500" i="1">
+                <a:solidFill>
+                  <a:srgbClr val="777777"/>
+                </a:solidFill>
+              </a:rPr>
+              <a:t>   Ela assistiu o filme no teatro.</a:t>
+            </a:r>
+          </a:p>
+          <a:p>
+            <a:pPr>
+              <a:spcAft>
+                <a:spcPts val="1000"/>
+              </a:spcAft>
+            </a:pPr>
+          </a:p>
+          <a:p>
+            <a:r>
+              <a:rPr sz="1800" b="1">
+                <a:solidFill>
+                  <a:srgbClr val="1A1A1A"/>
+                </a:solidFill>
+              </a:rPr>
+              <a:t>▸ He waited for the message.</a:t>
+            </a:r>
+          </a:p>
+          <a:p>
+            <a:pPr>
+              <a:spcAft>
+                <a:spcPts val="1000"/>
+              </a:spcAft>
+            </a:pPr>
+            <a:r>
+              <a:rPr sz="1500" i="1">
+                <a:solidFill>
+                  <a:srgbClr val="777777"/>
+                </a:solidFill>
+              </a:rPr>
+              <a:t>   Ele esperou pela mensagem.</a:t>
+            </a:r>
+          </a:p>
+          <a:p>
+            <a:pPr>
+              <a:spcAft>
+                <a:spcPts val="1000"/>
+              </a:spcAft>
+            </a:pPr>
+          </a:p>
+          <a:p>
+            <a:r>
+              <a:rPr sz="1800" b="1">
+                <a:solidFill>
+                  <a:srgbClr val="1A1A1A"/>
+                </a:solidFill>
+              </a:rPr>
+              <a:t>▸ There was an actor at the amusement park.</a:t>
+            </a:r>
+          </a:p>
+          <a:p>
+            <a:pPr>
+              <a:spcAft>
+                <a:spcPts val="1000"/>
+              </a:spcAft>
+            </a:pPr>
+            <a:r>
+              <a:rPr sz="1500" i="1">
+                <a:solidFill>
+                  <a:srgbClr val="777777"/>
+                </a:solidFill>
+              </a:rPr>
+              <a:t>   Tinha um ator no parque de diversões.</a:t>
+            </a:r>
+          </a:p>
+          <a:p>
+            <a:pPr>
+              <a:spcAft>
+                <a:spcPts val="1000"/>
+              </a:spcAft>
+            </a:pPr>
+          </a:p>
+          <a:p>
+            <a:r>
+              <a:rPr sz="1800" b="1">
+                <a:solidFill>
+                  <a:srgbClr val="1A1A1A"/>
+                </a:solidFill>
+              </a:rPr>
+              <a:t>▸ There were both pictures and cameras.</a:t>
+            </a:r>
+          </a:p>
+          <a:p>
+            <a:pPr>
+              <a:spcAft>
+                <a:spcPts val="1000"/>
+              </a:spcAft>
+            </a:pPr>
+            <a:r>
+              <a:rPr sz="1500" i="1">
+                <a:solidFill>
+                  <a:srgbClr val="777777"/>
+                </a:solidFill>
+              </a:rPr>
+              <a:t>   Tinham tanto fotos quanto câmeras.</a:t>
+            </a:r>
+          </a:p>
+          <a:p>
+            <a:pPr>
+              <a:spcAft>
+                <a:spcPts val="1000"/>
+              </a:spcAft>
+            </a:pPr>
+          </a:p>
+          <a:p>
+            <a:r>
+              <a:rPr sz="1800" b="1">
+                <a:solidFill>
+                  <a:srgbClr val="1A1A1A"/>
+                </a:solidFill>
+              </a:rPr>
+              <a:t>▸ I left a moment ago.</a:t>
+            </a:r>
+          </a:p>
+          <a:p>
+            <a:pPr>
+              <a:spcAft>
+                <a:spcPts val="1000"/>
+              </a:spcAft>
+            </a:pPr>
+            <a:r>
+              <a:rPr sz="1500" i="1">
+                <a:solidFill>
+                  <a:srgbClr val="777777"/>
+                </a:solidFill>
+              </a:rPr>
+              <a:t>   Eu saí um momento atrás.</a:t>
+            </a:r>
+          </a:p>
+        </p:txBody>
+      </p:sp>
+      <p:sp>
+        <p:nvSpPr>
+          <p:cNvPr id="5" name="TextBox 4"/>
+          <p:cNvSpPr txBox="1"/>
+          <p:nvPr/>
+        </p:nvSpPr>
+        <p:spPr>
+          <a:xfrm>
+            <a:off x="914400" y="6309360"/>
+            <a:ext cx="7772400" cy="457200"/>
+          </a:xfrm>
+          <a:prstGeom prst="rect">
+            <a:avLst/>
+          </a:prstGeom>
+          <a:noFill/>
+        </p:spPr>
+        <p:txBody>
+          <a:bodyPr wrap="none">
+            <a:spAutoFit/>
+          </a:bodyPr>
+          <a:lstStyle/>
+          <a:p>
+            <a:pPr algn="ctr"/>
+            <a:r>
+              <a:rPr sz="1200">
+                <a:solidFill>
+                  <a:srgbClr val="999999"/>
+                </a:solidFill>
+              </a:rPr>
+              <a:t>www.rawenglish.com.br</a:t>
+            </a:r>
+          </a:p>
+        </p:txBody>
+      </p:sp>
+    </p:spTree>
+  </p:cSld>
+  <p:clrMapOvr>
+    <a:masterClrMapping/>
+  </p:clrMapOvr>
+</p:sld>
+</file>
+
+<file path=ppt/slides/slide34.xml><?xml version="1.0" encoding="utf-8"?>
+<p:sld xmlns:a="http://schemas.openxmlformats.org/drawingml/2006/main" xmlns:p="http://schemas.openxmlformats.org/presentationml/2006/main" xmlns:r="http://schemas.openxmlformats.org/officeDocument/2006/relationships">
+  <p:cSld>
+    <p:spTree>
+      <p:nvGrpSpPr>
+        <p:cNvPr id="1" name=""/>
+        <p:cNvGrpSpPr/>
+        <p:nvPr/>
+      </p:nvGrpSpPr>
+      <p:grpSpPr/>
+      <p:sp>
+        <p:nvSpPr>
+          <p:cNvPr id="2" name="TextBox 1"/>
+          <p:cNvSpPr txBox="1"/>
+          <p:nvPr/>
+        </p:nvSpPr>
+        <p:spPr>
+          <a:xfrm>
+            <a:off x="914400" y="457200"/>
+            <a:ext cx="7772400" cy="731520"/>
+          </a:xfrm>
+          <a:prstGeom prst="rect">
+            <a:avLst/>
+          </a:prstGeom>
+          <a:noFill/>
+        </p:spPr>
+        <p:txBody>
+          <a:bodyPr wrap="none">
+            <a:spAutoFit/>
+          </a:bodyPr>
+          <a:lstStyle/>
+          <a:p>
+            <a:pPr algn="ctr"/>
+            <a:r>
+              <a:rPr sz="2800" b="1">
+                <a:solidFill>
+                  <a:srgbClr val="333333"/>
+                </a:solidFill>
+              </a:rPr>
+              <a:t>Lesson 9</a:t>
+            </a:r>
+          </a:p>
+        </p:txBody>
+      </p:sp>
+      <p:sp>
+        <p:nvSpPr>
+          <p:cNvPr id="3" name="TextBox 2"/>
+          <p:cNvSpPr txBox="1"/>
+          <p:nvPr/>
+        </p:nvSpPr>
+        <p:spPr>
+          <a:xfrm>
+            <a:off x="914400" y="1097280"/>
+            <a:ext cx="7772400" cy="548640"/>
+          </a:xfrm>
+          <a:prstGeom prst="rect">
+            <a:avLst/>
+          </a:prstGeom>
+          <a:noFill/>
+        </p:spPr>
+        <p:txBody>
+          <a:bodyPr wrap="none">
+            <a:spAutoFit/>
+          </a:bodyPr>
+          <a:lstStyle/>
+          <a:p>
+            <a:pPr algn="ctr"/>
+            <a:r>
+              <a:rPr sz="2400" b="1">
+                <a:solidFill>
+                  <a:srgbClr val="E86C00"/>
+                </a:solidFill>
+              </a:rPr>
+              <a:t>PRACTICE / PRATIQUE</a:t>
+            </a:r>
+          </a:p>
+        </p:txBody>
+      </p:sp>
+      <p:sp>
+        <p:nvSpPr>
+          <p:cNvPr id="4" name="TextBox 3"/>
+          <p:cNvSpPr txBox="1"/>
+          <p:nvPr/>
+        </p:nvSpPr>
+        <p:spPr>
+          <a:xfrm>
+            <a:off x="1097280" y="1645920"/>
+            <a:ext cx="9144000" cy="4114800"/>
+          </a:xfrm>
+          <a:prstGeom prst="rect">
+            <a:avLst/>
+          </a:prstGeom>
+          <a:noFill/>
+        </p:spPr>
+        <p:txBody>
+          <a:bodyPr wrap="square" anchor="t">
+            <a:spAutoFit/>
+          </a:bodyPr>
+          <a:lstStyle/>
+          <a:p>
+            <a:r>
+              <a:rPr sz="1800" b="1">
+                <a:solidFill>
+                  <a:srgbClr val="1A1A1A"/>
+                </a:solidFill>
+              </a:rPr>
+              <a:t>▸ I arrived and put my clothes in the room.</a:t>
+            </a:r>
+          </a:p>
+          <a:p>
+            <a:pPr>
+              <a:spcAft>
+                <a:spcPts val="1000"/>
+              </a:spcAft>
+            </a:pPr>
+            <a:r>
+              <a:rPr sz="1500" i="1">
+                <a:solidFill>
+                  <a:srgbClr val="777777"/>
+                </a:solidFill>
+              </a:rPr>
+              <a:t>   Eu cheguei e coloquei minhas roupas no quarto.</a:t>
+            </a:r>
+          </a:p>
+          <a:p>
+            <a:pPr>
+              <a:spcAft>
+                <a:spcPts val="1000"/>
+              </a:spcAft>
+            </a:pPr>
+          </a:p>
+          <a:p>
+            <a:r>
+              <a:rPr sz="1800" b="1">
+                <a:solidFill>
+                  <a:srgbClr val="1A1A1A"/>
+                </a:solidFill>
+              </a:rPr>
+              <a:t>▸ She rented a pair of sneakers.</a:t>
+            </a:r>
+          </a:p>
+          <a:p>
+            <a:pPr>
+              <a:spcAft>
+                <a:spcPts val="1000"/>
+              </a:spcAft>
+            </a:pPr>
+            <a:r>
+              <a:rPr sz="1500" i="1">
+                <a:solidFill>
+                  <a:srgbClr val="777777"/>
+                </a:solidFill>
+              </a:rPr>
+              <a:t>   Ela alugou um par de tênis.</a:t>
+            </a:r>
+          </a:p>
+          <a:p>
+            <a:pPr>
+              <a:spcAft>
+                <a:spcPts val="1000"/>
+              </a:spcAft>
+            </a:pPr>
+          </a:p>
+          <a:p>
+            <a:r>
+              <a:rPr sz="1800" b="1">
+                <a:solidFill>
+                  <a:srgbClr val="1A1A1A"/>
+                </a:solidFill>
+              </a:rPr>
+              <a:t>▸ He put the passport and the receipt together.</a:t>
+            </a:r>
+          </a:p>
+          <a:p>
+            <a:pPr>
+              <a:spcAft>
+                <a:spcPts val="1000"/>
+              </a:spcAft>
+            </a:pPr>
+            <a:r>
+              <a:rPr sz="1500" i="1">
+                <a:solidFill>
+                  <a:srgbClr val="777777"/>
+                </a:solidFill>
+              </a:rPr>
+              <a:t>   Ele colocou o passaporte e o recibo juntos.</a:t>
+            </a:r>
+          </a:p>
+          <a:p>
+            <a:pPr>
+              <a:spcAft>
+                <a:spcPts val="1000"/>
+              </a:spcAft>
+            </a:pPr>
+          </a:p>
+          <a:p>
+            <a:r>
+              <a:rPr sz="1800" b="1">
+                <a:solidFill>
+                  <a:srgbClr val="1A1A1A"/>
+                </a:solidFill>
+              </a:rPr>
+              <a:t>▸ The weather was rainy and I needed my cap.</a:t>
+            </a:r>
+          </a:p>
+          <a:p>
+            <a:pPr>
+              <a:spcAft>
+                <a:spcPts val="1000"/>
+              </a:spcAft>
+            </a:pPr>
+            <a:r>
+              <a:rPr sz="1500" i="1">
+                <a:solidFill>
+                  <a:srgbClr val="777777"/>
+                </a:solidFill>
+              </a:rPr>
+              <a:t>   O tempo estava chuvoso e eu precisei do meu boné.</a:t>
+            </a:r>
+          </a:p>
+          <a:p>
+            <a:pPr>
+              <a:spcAft>
+                <a:spcPts val="1000"/>
+              </a:spcAft>
+            </a:pPr>
+          </a:p>
+          <a:p>
+            <a:r>
+              <a:rPr sz="1800" b="1">
+                <a:solidFill>
+                  <a:srgbClr val="1A1A1A"/>
+                </a:solidFill>
+              </a:rPr>
+              <a:t>▸ What's this like? A penny, a nickel, and a dime.</a:t>
+            </a:r>
+          </a:p>
+          <a:p>
+            <a:pPr>
+              <a:spcAft>
+                <a:spcPts val="1000"/>
+              </a:spcAft>
+            </a:pPr>
+            <a:r>
+              <a:rPr sz="1500" i="1">
+                <a:solidFill>
+                  <a:srgbClr val="777777"/>
+                </a:solidFill>
+              </a:rPr>
+              <a:t>   Como é isso? Um centavo, cinco centavos e dez centavos.</a:t>
+            </a:r>
+          </a:p>
+          <a:p>
+            <a:pPr>
+              <a:spcAft>
+                <a:spcPts val="1000"/>
+              </a:spcAft>
+            </a:pPr>
+          </a:p>
+          <a:p>
+            <a:r>
+              <a:rPr sz="1800" b="1">
+                <a:solidFill>
+                  <a:srgbClr val="1A1A1A"/>
+                </a:solidFill>
+              </a:rPr>
+              <a:t>▸ I put on my belt, pants, and shoes.</a:t>
+            </a:r>
+          </a:p>
+          <a:p>
+            <a:pPr>
+              <a:spcAft>
+                <a:spcPts val="1000"/>
+              </a:spcAft>
+            </a:pPr>
+            <a:r>
+              <a:rPr sz="1500" i="1">
+                <a:solidFill>
+                  <a:srgbClr val="777777"/>
+                </a:solidFill>
+              </a:rPr>
+              <a:t>   Eu coloquei meu cinto, calça e sapatos.</a:t>
+            </a:r>
+          </a:p>
+        </p:txBody>
+      </p:sp>
+      <p:sp>
+        <p:nvSpPr>
+          <p:cNvPr id="5" name="TextBox 4"/>
+          <p:cNvSpPr txBox="1"/>
+          <p:nvPr/>
+        </p:nvSpPr>
+        <p:spPr>
+          <a:xfrm>
+            <a:off x="914400" y="6309360"/>
+            <a:ext cx="7772400" cy="457200"/>
+          </a:xfrm>
+          <a:prstGeom prst="rect">
+            <a:avLst/>
+          </a:prstGeom>
+          <a:noFill/>
+        </p:spPr>
+        <p:txBody>
+          <a:bodyPr wrap="none">
+            <a:spAutoFit/>
+          </a:bodyPr>
+          <a:lstStyle/>
+          <a:p>
+            <a:pPr algn="ctr"/>
+            <a:r>
+              <a:rPr sz="1200">
+                <a:solidFill>
+                  <a:srgbClr val="999999"/>
+                </a:solidFill>
+              </a:rPr>
+              <a:t>www.rawenglish.com.br</a:t>
+            </a:r>
+          </a:p>
+        </p:txBody>
+      </p:sp>
+    </p:spTree>
+  </p:cSld>
+  <p:clrMapOvr>
+    <a:masterClrMapping/>
+  </p:clrMapOvr>
+</p:sld>
+</file>
+
+<file path=ppt/slides/slide35.xml><?xml version="1.0" encoding="utf-8"?>
+<p:sld xmlns:a="http://schemas.openxmlformats.org/drawingml/2006/main" xmlns:p="http://schemas.openxmlformats.org/presentationml/2006/main" xmlns:r="http://schemas.openxmlformats.org/officeDocument/2006/relationships">
+  <p:cSld>
+    <p:spTree>
+      <p:nvGrpSpPr>
+        <p:cNvPr id="1" name=""/>
+        <p:cNvGrpSpPr/>
+        <p:nvPr/>
+      </p:nvGrpSpPr>
+      <p:grpSpPr/>
+      <p:sp>
+        <p:nvSpPr>
+          <p:cNvPr id="2" name="TextBox 1"/>
+          <p:cNvSpPr txBox="1"/>
+          <p:nvPr/>
+        </p:nvSpPr>
+        <p:spPr>
+          <a:xfrm>
+            <a:off x="914400" y="457200"/>
+            <a:ext cx="7772400" cy="731520"/>
+          </a:xfrm>
+          <a:prstGeom prst="rect">
+            <a:avLst/>
+          </a:prstGeom>
+          <a:noFill/>
+        </p:spPr>
+        <p:txBody>
+          <a:bodyPr wrap="none">
+            <a:spAutoFit/>
+          </a:bodyPr>
+          <a:lstStyle/>
+          <a:p>
+            <a:pPr algn="ctr"/>
+            <a:r>
+              <a:rPr sz="2800" b="1">
+                <a:solidFill>
+                  <a:srgbClr val="333333"/>
+                </a:solidFill>
+              </a:rPr>
+              <a:t>Lesson 10</a:t>
+            </a:r>
+          </a:p>
+        </p:txBody>
+      </p:sp>
+      <p:sp>
+        <p:nvSpPr>
+          <p:cNvPr id="3" name="TextBox 2"/>
+          <p:cNvSpPr txBox="1"/>
+          <p:nvPr/>
+        </p:nvSpPr>
+        <p:spPr>
+          <a:xfrm>
+            <a:off x="914400" y="1097280"/>
+            <a:ext cx="7772400" cy="548640"/>
+          </a:xfrm>
+          <a:prstGeom prst="rect">
+            <a:avLst/>
+          </a:prstGeom>
+          <a:noFill/>
+        </p:spPr>
+        <p:txBody>
+          <a:bodyPr wrap="none">
+            <a:spAutoFit/>
+          </a:bodyPr>
+          <a:lstStyle/>
+          <a:p>
+            <a:pPr algn="ctr"/>
+            <a:r>
+              <a:rPr sz="2400" b="1">
+                <a:solidFill>
+                  <a:srgbClr val="E86C00"/>
+                </a:solidFill>
+              </a:rPr>
+              <a:t>PRACTICE / PRATIQUE</a:t>
+            </a:r>
+          </a:p>
+        </p:txBody>
+      </p:sp>
+      <p:sp>
+        <p:nvSpPr>
+          <p:cNvPr id="4" name="TextBox 3"/>
+          <p:cNvSpPr txBox="1"/>
+          <p:nvPr/>
+        </p:nvSpPr>
+        <p:spPr>
+          <a:xfrm>
+            <a:off x="1097280" y="1645920"/>
+            <a:ext cx="9144000" cy="4114800"/>
+          </a:xfrm>
+          <a:prstGeom prst="rect">
+            <a:avLst/>
+          </a:prstGeom>
+          <a:noFill/>
+        </p:spPr>
+        <p:txBody>
+          <a:bodyPr wrap="square" anchor="t">
+            <a:spAutoFit/>
+          </a:bodyPr>
+          <a:lstStyle/>
+          <a:p>
+            <a:r>
+              <a:rPr sz="1800" b="1">
+                <a:solidFill>
+                  <a:srgbClr val="1A1A1A"/>
+                </a:solidFill>
+              </a:rPr>
+              <a:t>▸ I thought about it and went to the store.</a:t>
+            </a:r>
+          </a:p>
+          <a:p>
+            <a:pPr>
+              <a:spcAft>
+                <a:spcPts val="1000"/>
+              </a:spcAft>
+            </a:pPr>
+            <a:r>
+              <a:rPr sz="1500" i="1">
+                <a:solidFill>
+                  <a:srgbClr val="777777"/>
+                </a:solidFill>
+              </a:rPr>
+              <a:t>   Eu pensei nisso e fui à loja.</a:t>
+            </a:r>
+          </a:p>
+          <a:p>
+            <a:pPr>
+              <a:spcAft>
+                <a:spcPts val="1000"/>
+              </a:spcAft>
+            </a:pPr>
+          </a:p>
+          <a:p>
+            <a:r>
+              <a:rPr sz="1800" b="1">
+                <a:solidFill>
+                  <a:srgbClr val="1A1A1A"/>
+                </a:solidFill>
+              </a:rPr>
+              <a:t>▸ She asked and he answered right away.</a:t>
+            </a:r>
+          </a:p>
+          <a:p>
+            <a:pPr>
+              <a:spcAft>
+                <a:spcPts val="1000"/>
+              </a:spcAft>
+            </a:pPr>
+            <a:r>
+              <a:rPr sz="1500" i="1">
+                <a:solidFill>
+                  <a:srgbClr val="777777"/>
+                </a:solidFill>
+              </a:rPr>
+              <a:t>   Ela perguntou e ele respondeu na hora.</a:t>
+            </a:r>
+          </a:p>
+          <a:p>
+            <a:pPr>
+              <a:spcAft>
+                <a:spcPts val="1000"/>
+              </a:spcAft>
+            </a:pPr>
+          </a:p>
+          <a:p>
+            <a:r>
+              <a:rPr sz="1800" b="1">
+                <a:solidFill>
+                  <a:srgbClr val="1A1A1A"/>
+                </a:solidFill>
+              </a:rPr>
+              <a:t>▸ There was a movie but I left early.</a:t>
+            </a:r>
+          </a:p>
+          <a:p>
+            <a:pPr>
+              <a:spcAft>
+                <a:spcPts val="1000"/>
+              </a:spcAft>
+            </a:pPr>
+            <a:r>
+              <a:rPr sz="1500" i="1">
+                <a:solidFill>
+                  <a:srgbClr val="777777"/>
+                </a:solidFill>
+              </a:rPr>
+              <a:t>   Tinha um filme mas eu saí cedo.</a:t>
+            </a:r>
+          </a:p>
+          <a:p>
+            <a:pPr>
+              <a:spcAft>
+                <a:spcPts val="1000"/>
+              </a:spcAft>
+            </a:pPr>
+          </a:p>
+          <a:p>
+            <a:r>
+              <a:rPr sz="1800" b="1">
+                <a:solidFill>
+                  <a:srgbClr val="1A1A1A"/>
+                </a:solidFill>
+              </a:rPr>
+              <a:t>▸ We arrived, sat down, and waited.</a:t>
+            </a:r>
+          </a:p>
+          <a:p>
+            <a:pPr>
+              <a:spcAft>
+                <a:spcPts val="1000"/>
+              </a:spcAft>
+            </a:pPr>
+            <a:r>
+              <a:rPr sz="1500" i="1">
+                <a:solidFill>
+                  <a:srgbClr val="777777"/>
+                </a:solidFill>
+              </a:rPr>
+              <a:t>   Nós chegamos, sentamos e esperamos.</a:t>
+            </a:r>
+          </a:p>
+          <a:p>
+            <a:pPr>
+              <a:spcAft>
+                <a:spcPts val="1000"/>
+              </a:spcAft>
+            </a:pPr>
+          </a:p>
+          <a:p>
+            <a:r>
+              <a:rPr sz="1800" b="1">
+                <a:solidFill>
+                  <a:srgbClr val="1A1A1A"/>
+                </a:solidFill>
+              </a:rPr>
+              <a:t>▸ He rented a car and watched the sunset.</a:t>
+            </a:r>
+          </a:p>
+          <a:p>
+            <a:pPr>
+              <a:spcAft>
+                <a:spcPts val="1000"/>
+              </a:spcAft>
+            </a:pPr>
+            <a:r>
+              <a:rPr sz="1500" i="1">
+                <a:solidFill>
+                  <a:srgbClr val="777777"/>
+                </a:solidFill>
+              </a:rPr>
+              <a:t>   Ele alugou um carro e assistiu o pôr do sol.</a:t>
+            </a:r>
+          </a:p>
+          <a:p>
+            <a:pPr>
+              <a:spcAft>
+                <a:spcPts val="1000"/>
+              </a:spcAft>
+            </a:pPr>
+          </a:p>
+          <a:p>
+            <a:r>
+              <a:rPr sz="1800" b="1">
+                <a:solidFill>
+                  <a:srgbClr val="1A1A1A"/>
+                </a:solidFill>
+              </a:rPr>
+              <a:t>▸ I cooked and talked with my grandchildren.</a:t>
+            </a:r>
+          </a:p>
+          <a:p>
+            <a:pPr>
+              <a:spcAft>
+                <a:spcPts val="1000"/>
+              </a:spcAft>
+            </a:pPr>
+            <a:r>
+              <a:rPr sz="1500" i="1">
+                <a:solidFill>
+                  <a:srgbClr val="777777"/>
+                </a:solidFill>
+              </a:rPr>
+              <a:t>   Eu cozinhei e conversei com meus netos.</a:t>
+            </a:r>
+          </a:p>
+        </p:txBody>
+      </p:sp>
+      <p:sp>
+        <p:nvSpPr>
+          <p:cNvPr id="5" name="TextBox 4"/>
+          <p:cNvSpPr txBox="1"/>
+          <p:nvPr/>
+        </p:nvSpPr>
+        <p:spPr>
+          <a:xfrm>
+            <a:off x="914400" y="6309360"/>
+            <a:ext cx="7772400" cy="457200"/>
+          </a:xfrm>
+          <a:prstGeom prst="rect">
+            <a:avLst/>
+          </a:prstGeom>
+          <a:noFill/>
+        </p:spPr>
+        <p:txBody>
+          <a:bodyPr wrap="none">
+            <a:spAutoFit/>
+          </a:bodyPr>
+          <a:lstStyle/>
+          <a:p>
+            <a:pPr algn="ctr"/>
+            <a:r>
+              <a:rPr sz="1200">
+                <a:solidFill>
+                  <a:srgbClr val="999999"/>
+                </a:solidFill>
+              </a:rPr>
+              <a:t>www.rawenglish.com.br</a:t>
+            </a:r>
+          </a:p>
+        </p:txBody>
+      </p:sp>
+    </p:spTree>
+  </p:cSld>
+  <p:clrMapOvr>
+    <a:masterClrMapping/>
+  </p:clrMapOvr>
+</p:sld>
+</file>
+
+<file path=ppt/slides/slide36.xml><?xml version="1.0" encoding="utf-8"?>
+<p:sld xmlns:a="http://schemas.openxmlformats.org/drawingml/2006/main" xmlns:p="http://schemas.openxmlformats.org/presentationml/2006/main" xmlns:r="http://schemas.openxmlformats.org/officeDocument/2006/relationships">
+  <p:cSld>
+    <p:spTree>
+      <p:nvGrpSpPr>
+        <p:cNvPr id="1" name=""/>
+        <p:cNvGrpSpPr/>
+        <p:nvPr/>
+      </p:nvGrpSpPr>
+      <p:grpSpPr/>
+      <p:sp>
+        <p:nvSpPr>
+          <p:cNvPr id="2" name="TextBox 1"/>
+          <p:cNvSpPr txBox="1"/>
+          <p:nvPr/>
+        </p:nvSpPr>
+        <p:spPr>
+          <a:xfrm>
+            <a:off x="914400" y="457200"/>
+            <a:ext cx="7772400" cy="731520"/>
+          </a:xfrm>
+          <a:prstGeom prst="rect">
+            <a:avLst/>
+          </a:prstGeom>
+          <a:noFill/>
+        </p:spPr>
+        <p:txBody>
+          <a:bodyPr wrap="none">
+            <a:spAutoFit/>
+          </a:bodyPr>
+          <a:lstStyle/>
+          <a:p>
+            <a:pPr algn="ctr"/>
+            <a:r>
+              <a:rPr sz="2800" b="1">
+                <a:solidFill>
+                  <a:srgbClr val="333333"/>
+                </a:solidFill>
+              </a:rPr>
+              <a:t>Lesson 11</a:t>
+            </a:r>
+          </a:p>
+        </p:txBody>
+      </p:sp>
+      <p:sp>
+        <p:nvSpPr>
+          <p:cNvPr id="3" name="TextBox 2"/>
+          <p:cNvSpPr txBox="1"/>
+          <p:nvPr/>
+        </p:nvSpPr>
+        <p:spPr>
+          <a:xfrm>
+            <a:off x="914400" y="1097280"/>
+            <a:ext cx="7772400" cy="548640"/>
+          </a:xfrm>
+          <a:prstGeom prst="rect">
+            <a:avLst/>
+          </a:prstGeom>
+          <a:noFill/>
+        </p:spPr>
+        <p:txBody>
+          <a:bodyPr wrap="none">
+            <a:spAutoFit/>
+          </a:bodyPr>
+          <a:lstStyle/>
+          <a:p>
+            <a:pPr algn="ctr"/>
+            <a:r>
+              <a:rPr sz="2400" b="1">
+                <a:solidFill>
+                  <a:srgbClr val="E86C00"/>
+                </a:solidFill>
+              </a:rPr>
+              <a:t>PRACTICE / PRATIQUE</a:t>
+            </a:r>
+          </a:p>
+        </p:txBody>
+      </p:sp>
+      <p:sp>
+        <p:nvSpPr>
+          <p:cNvPr id="4" name="TextBox 3"/>
+          <p:cNvSpPr txBox="1"/>
+          <p:nvPr/>
+        </p:nvSpPr>
+        <p:spPr>
+          <a:xfrm>
+            <a:off x="1097280" y="1645920"/>
+            <a:ext cx="9144000" cy="4114800"/>
+          </a:xfrm>
+          <a:prstGeom prst="rect">
+            <a:avLst/>
+          </a:prstGeom>
+          <a:noFill/>
+        </p:spPr>
+        <p:txBody>
+          <a:bodyPr wrap="square" anchor="t">
+            <a:spAutoFit/>
+          </a:bodyPr>
+          <a:lstStyle/>
+          <a:p>
+            <a:r>
+              <a:rPr sz="1800" b="1">
+                <a:solidFill>
+                  <a:srgbClr val="1A1A1A"/>
+                </a:solidFill>
+              </a:rPr>
+              <a:t>▸ I understood the lesson in the bedroom.</a:t>
+            </a:r>
+          </a:p>
+          <a:p>
+            <a:pPr>
+              <a:spcAft>
+                <a:spcPts val="1000"/>
+              </a:spcAft>
+            </a:pPr>
+            <a:r>
+              <a:rPr sz="1500" i="1">
+                <a:solidFill>
+                  <a:srgbClr val="777777"/>
+                </a:solidFill>
+              </a:rPr>
+              <a:t>   Eu entendi a lição no quarto.</a:t>
+            </a:r>
+          </a:p>
+          <a:p>
+            <a:pPr>
+              <a:spcAft>
+                <a:spcPts val="1000"/>
+              </a:spcAft>
+            </a:pPr>
+          </a:p>
+          <a:p>
+            <a:r>
+              <a:rPr sz="1800" b="1">
+                <a:solidFill>
+                  <a:srgbClr val="1A1A1A"/>
+                </a:solidFill>
+              </a:rPr>
+              <a:t>▸ She cleaned the living room and the kitchen.</a:t>
+            </a:r>
+          </a:p>
+          <a:p>
+            <a:pPr>
+              <a:spcAft>
+                <a:spcPts val="1000"/>
+              </a:spcAft>
+            </a:pPr>
+            <a:r>
+              <a:rPr sz="1500" i="1">
+                <a:solidFill>
+                  <a:srgbClr val="777777"/>
+                </a:solidFill>
+              </a:rPr>
+              <a:t>   Ela limpou a sala e a cozinha.</a:t>
+            </a:r>
+          </a:p>
+          <a:p>
+            <a:pPr>
+              <a:spcAft>
+                <a:spcPts val="1000"/>
+              </a:spcAft>
+            </a:pPr>
+          </a:p>
+          <a:p>
+            <a:r>
+              <a:rPr sz="1800" b="1">
+                <a:solidFill>
+                  <a:srgbClr val="1A1A1A"/>
+                </a:solidFill>
+              </a:rPr>
+              <a:t>▸ He washed the dishes with soap.</a:t>
+            </a:r>
+          </a:p>
+          <a:p>
+            <a:pPr>
+              <a:spcAft>
+                <a:spcPts val="1000"/>
+              </a:spcAft>
+            </a:pPr>
+            <a:r>
+              <a:rPr sz="1500" i="1">
+                <a:solidFill>
+                  <a:srgbClr val="777777"/>
+                </a:solidFill>
+              </a:rPr>
+              <a:t>   Ele lavou a louça com sabão.</a:t>
+            </a:r>
+          </a:p>
+          <a:p>
+            <a:pPr>
+              <a:spcAft>
+                <a:spcPts val="1000"/>
+              </a:spcAft>
+            </a:pPr>
+          </a:p>
+          <a:p>
+            <a:r>
+              <a:rPr sz="1800" b="1">
+                <a:solidFill>
+                  <a:srgbClr val="1A1A1A"/>
+                </a:solidFill>
+              </a:rPr>
+              <a:t>▸ I looked at the garden from the garage.</a:t>
+            </a:r>
+          </a:p>
+          <a:p>
+            <a:pPr>
+              <a:spcAft>
+                <a:spcPts val="1000"/>
+              </a:spcAft>
+            </a:pPr>
+            <a:r>
+              <a:rPr sz="1500" i="1">
+                <a:solidFill>
+                  <a:srgbClr val="777777"/>
+                </a:solidFill>
+              </a:rPr>
+              <a:t>   Eu olhei para o jardim da garagem.</a:t>
+            </a:r>
+          </a:p>
+          <a:p>
+            <a:pPr>
+              <a:spcAft>
+                <a:spcPts val="1000"/>
+              </a:spcAft>
+            </a:pPr>
+          </a:p>
+          <a:p>
+            <a:r>
+              <a:rPr sz="1800" b="1">
+                <a:solidFill>
+                  <a:srgbClr val="1A1A1A"/>
+                </a:solidFill>
+              </a:rPr>
+              <a:t>▸ How old are you? I took a shower.</a:t>
+            </a:r>
+          </a:p>
+          <a:p>
+            <a:pPr>
+              <a:spcAft>
+                <a:spcPts val="1000"/>
+              </a:spcAft>
+            </a:pPr>
+            <a:r>
+              <a:rPr sz="1500" i="1">
+                <a:solidFill>
+                  <a:srgbClr val="777777"/>
+                </a:solidFill>
+              </a:rPr>
+              <a:t>   Quantos anos você tem? Eu tomei banho.</a:t>
+            </a:r>
+          </a:p>
+          <a:p>
+            <a:pPr>
+              <a:spcAft>
+                <a:spcPts val="1000"/>
+              </a:spcAft>
+            </a:pPr>
+          </a:p>
+          <a:p>
+            <a:r>
+              <a:rPr sz="1800" b="1">
+                <a:solidFill>
+                  <a:srgbClr val="1A1A1A"/>
+                </a:solidFill>
+              </a:rPr>
+              <a:t>▸ She looks like her mother a little.</a:t>
+            </a:r>
+          </a:p>
+          <a:p>
+            <a:pPr>
+              <a:spcAft>
+                <a:spcPts val="1000"/>
+              </a:spcAft>
+            </a:pPr>
+            <a:r>
+              <a:rPr sz="1500" i="1">
+                <a:solidFill>
+                  <a:srgbClr val="777777"/>
+                </a:solidFill>
+              </a:rPr>
+              <a:t>   Ela se parece um pouco com a mãe.</a:t>
+            </a:r>
+          </a:p>
+        </p:txBody>
+      </p:sp>
+      <p:sp>
+        <p:nvSpPr>
+          <p:cNvPr id="5" name="TextBox 4"/>
+          <p:cNvSpPr txBox="1"/>
+          <p:nvPr/>
+        </p:nvSpPr>
+        <p:spPr>
+          <a:xfrm>
+            <a:off x="914400" y="6309360"/>
+            <a:ext cx="7772400" cy="457200"/>
+          </a:xfrm>
+          <a:prstGeom prst="rect">
+            <a:avLst/>
+          </a:prstGeom>
+          <a:noFill/>
+        </p:spPr>
+        <p:txBody>
+          <a:bodyPr wrap="none">
+            <a:spAutoFit/>
+          </a:bodyPr>
+          <a:lstStyle/>
+          <a:p>
+            <a:pPr algn="ctr"/>
+            <a:r>
+              <a:rPr sz="1200">
+                <a:solidFill>
+                  <a:srgbClr val="999999"/>
+                </a:solidFill>
+              </a:rPr>
+              <a:t>www.rawenglish.com.br</a:t>
+            </a:r>
+          </a:p>
+        </p:txBody>
+      </p:sp>
+    </p:spTree>
+  </p:cSld>
+  <p:clrMapOvr>
+    <a:masterClrMapping/>
+  </p:clrMapOvr>
+</p:sld>
+</file>
+
+<file path=ppt/slides/slide37.xml><?xml version="1.0" encoding="utf-8"?>
+<p:sld xmlns:a="http://schemas.openxmlformats.org/drawingml/2006/main" xmlns:p="http://schemas.openxmlformats.org/presentationml/2006/main" xmlns:r="http://schemas.openxmlformats.org/officeDocument/2006/relationships">
+  <p:cSld>
+    <p:spTree>
+      <p:nvGrpSpPr>
+        <p:cNvPr id="1" name=""/>
+        <p:cNvGrpSpPr/>
+        <p:nvPr/>
+      </p:nvGrpSpPr>
+      <p:grpSpPr/>
+      <p:sp>
+        <p:nvSpPr>
+          <p:cNvPr id="2" name="TextBox 1"/>
+          <p:cNvSpPr txBox="1"/>
+          <p:nvPr/>
+        </p:nvSpPr>
+        <p:spPr>
+          <a:xfrm>
+            <a:off x="914400" y="457200"/>
+            <a:ext cx="7772400" cy="731520"/>
+          </a:xfrm>
+          <a:prstGeom prst="rect">
+            <a:avLst/>
+          </a:prstGeom>
+          <a:noFill/>
+        </p:spPr>
+        <p:txBody>
+          <a:bodyPr wrap="none">
+            <a:spAutoFit/>
+          </a:bodyPr>
+          <a:lstStyle/>
+          <a:p>
+            <a:pPr algn="ctr"/>
+            <a:r>
+              <a:rPr sz="2800" b="1">
+                <a:solidFill>
+                  <a:srgbClr val="333333"/>
+                </a:solidFill>
+              </a:rPr>
+              <a:t>Lesson 12</a:t>
+            </a:r>
+          </a:p>
+        </p:txBody>
+      </p:sp>
+      <p:sp>
+        <p:nvSpPr>
+          <p:cNvPr id="3" name="TextBox 2"/>
+          <p:cNvSpPr txBox="1"/>
+          <p:nvPr/>
+        </p:nvSpPr>
+        <p:spPr>
+          <a:xfrm>
+            <a:off x="914400" y="1097280"/>
+            <a:ext cx="7772400" cy="548640"/>
+          </a:xfrm>
+          <a:prstGeom prst="rect">
+            <a:avLst/>
+          </a:prstGeom>
+          <a:noFill/>
+        </p:spPr>
+        <p:txBody>
+          <a:bodyPr wrap="none">
+            <a:spAutoFit/>
+          </a:bodyPr>
+          <a:lstStyle/>
+          <a:p>
+            <a:pPr algn="ctr"/>
+            <a:r>
+              <a:rPr sz="2400" b="1">
+                <a:solidFill>
+                  <a:srgbClr val="E86C00"/>
+                </a:solidFill>
+              </a:rPr>
+              <a:t>PRACTICE / PRATIQUE</a:t>
+            </a:r>
+          </a:p>
+        </p:txBody>
+      </p:sp>
+      <p:sp>
+        <p:nvSpPr>
+          <p:cNvPr id="4" name="TextBox 3"/>
+          <p:cNvSpPr txBox="1"/>
+          <p:nvPr/>
+        </p:nvSpPr>
+        <p:spPr>
+          <a:xfrm>
+            <a:off x="1097280" y="1645920"/>
+            <a:ext cx="9144000" cy="4114800"/>
+          </a:xfrm>
+          <a:prstGeom prst="rect">
+            <a:avLst/>
+          </a:prstGeom>
+          <a:noFill/>
+        </p:spPr>
+        <p:txBody>
+          <a:bodyPr wrap="square" anchor="t">
+            <a:spAutoFit/>
+          </a:bodyPr>
+          <a:lstStyle/>
+          <a:p>
+            <a:r>
+              <a:rPr sz="1800" b="1">
+                <a:solidFill>
+                  <a:srgbClr val="1A1A1A"/>
+                </a:solidFill>
+              </a:rPr>
+              <a:t>▸ The fork is on the plate.</a:t>
+            </a:r>
+          </a:p>
+          <a:p>
+            <a:pPr>
+              <a:spcAft>
+                <a:spcPts val="1000"/>
+              </a:spcAft>
+            </a:pPr>
+            <a:r>
+              <a:rPr sz="1500" i="1">
+                <a:solidFill>
+                  <a:srgbClr val="777777"/>
+                </a:solidFill>
+              </a:rPr>
+              <a:t>   O garfo está no prato.</a:t>
+            </a:r>
+          </a:p>
+          <a:p>
+            <a:pPr>
+              <a:spcAft>
+                <a:spcPts val="1000"/>
+              </a:spcAft>
+            </a:pPr>
+          </a:p>
+          <a:p>
+            <a:r>
+              <a:rPr sz="1800" b="1">
+                <a:solidFill>
+                  <a:srgbClr val="1A1A1A"/>
+                </a:solidFill>
+              </a:rPr>
+              <a:t>▸ She sat between the bed and the door.</a:t>
+            </a:r>
+          </a:p>
+          <a:p>
+            <a:pPr>
+              <a:spcAft>
+                <a:spcPts val="1000"/>
+              </a:spcAft>
+            </a:pPr>
+            <a:r>
+              <a:rPr sz="1500" i="1">
+                <a:solidFill>
+                  <a:srgbClr val="777777"/>
+                </a:solidFill>
+              </a:rPr>
+              <a:t>   Ela sentou entre a cama e a porta.</a:t>
+            </a:r>
+          </a:p>
+          <a:p>
+            <a:pPr>
+              <a:spcAft>
+                <a:spcPts val="1000"/>
+              </a:spcAft>
+            </a:pPr>
+          </a:p>
+          <a:p>
+            <a:r>
+              <a:rPr sz="1800" b="1">
+                <a:solidFill>
+                  <a:srgbClr val="1A1A1A"/>
+                </a:solidFill>
+              </a:rPr>
+              <a:t>▸ He went to the store in front of the park.</a:t>
+            </a:r>
+          </a:p>
+          <a:p>
+            <a:pPr>
+              <a:spcAft>
+                <a:spcPts val="1000"/>
+              </a:spcAft>
+            </a:pPr>
+            <a:r>
+              <a:rPr sz="1500" i="1">
+                <a:solidFill>
+                  <a:srgbClr val="777777"/>
+                </a:solidFill>
+              </a:rPr>
+              <a:t>   Ele foi à loja em frente ao parque.</a:t>
+            </a:r>
+          </a:p>
+          <a:p>
+            <a:pPr>
+              <a:spcAft>
+                <a:spcPts val="1000"/>
+              </a:spcAft>
+            </a:pPr>
+          </a:p>
+          <a:p>
+            <a:r>
+              <a:rPr sz="1800" b="1">
+                <a:solidFill>
+                  <a:srgbClr val="1A1A1A"/>
+                </a:solidFill>
+              </a:rPr>
+              <a:t>▸ I arrived at the hotel behind the church.</a:t>
+            </a:r>
+          </a:p>
+          <a:p>
+            <a:pPr>
+              <a:spcAft>
+                <a:spcPts val="1000"/>
+              </a:spcAft>
+            </a:pPr>
+            <a:r>
+              <a:rPr sz="1500" i="1">
+                <a:solidFill>
+                  <a:srgbClr val="777777"/>
+                </a:solidFill>
+              </a:rPr>
+              <a:t>   Eu cheguei no hotel atrás da igreja.</a:t>
+            </a:r>
+          </a:p>
+          <a:p>
+            <a:pPr>
+              <a:spcAft>
+                <a:spcPts val="1000"/>
+              </a:spcAft>
+            </a:pPr>
+          </a:p>
+          <a:p>
+            <a:r>
+              <a:rPr sz="1800" b="1">
+                <a:solidFill>
+                  <a:srgbClr val="1A1A1A"/>
+                </a:solidFill>
+              </a:rPr>
+              <a:t>▸ There is a napkin under the spoon.</a:t>
+            </a:r>
+          </a:p>
+          <a:p>
+            <a:pPr>
+              <a:spcAft>
+                <a:spcPts val="1000"/>
+              </a:spcAft>
+            </a:pPr>
+            <a:r>
+              <a:rPr sz="1500" i="1">
+                <a:solidFill>
+                  <a:srgbClr val="777777"/>
+                </a:solidFill>
+              </a:rPr>
+              <a:t>   Tem um guardanapo embaixo da colher.</a:t>
+            </a:r>
+          </a:p>
+          <a:p>
+            <a:pPr>
+              <a:spcAft>
+                <a:spcPts val="1000"/>
+              </a:spcAft>
+            </a:pPr>
+          </a:p>
+          <a:p>
+            <a:r>
+              <a:rPr sz="1800" b="1">
+                <a:solidFill>
+                  <a:srgbClr val="1A1A1A"/>
+                </a:solidFill>
+              </a:rPr>
+              <a:t>▸ We waited outside the bathroom.</a:t>
+            </a:r>
+          </a:p>
+          <a:p>
+            <a:pPr>
+              <a:spcAft>
+                <a:spcPts val="1000"/>
+              </a:spcAft>
+            </a:pPr>
+            <a:r>
+              <a:rPr sz="1500" i="1">
+                <a:solidFill>
+                  <a:srgbClr val="777777"/>
+                </a:solidFill>
+              </a:rPr>
+              <a:t>   Nós esperamos fora do banheiro.</a:t>
+            </a:r>
+          </a:p>
+        </p:txBody>
+      </p:sp>
+      <p:sp>
+        <p:nvSpPr>
+          <p:cNvPr id="5" name="TextBox 4"/>
+          <p:cNvSpPr txBox="1"/>
+          <p:nvPr/>
+        </p:nvSpPr>
+        <p:spPr>
+          <a:xfrm>
+            <a:off x="914400" y="6309360"/>
+            <a:ext cx="7772400" cy="457200"/>
+          </a:xfrm>
+          <a:prstGeom prst="rect">
+            <a:avLst/>
+          </a:prstGeom>
+          <a:noFill/>
+        </p:spPr>
+        <p:txBody>
+          <a:bodyPr wrap="none">
+            <a:spAutoFit/>
+          </a:bodyPr>
+          <a:lstStyle/>
+          <a:p>
+            <a:pPr algn="ctr"/>
+            <a:r>
+              <a:rPr sz="1200">
+                <a:solidFill>
+                  <a:srgbClr val="999999"/>
+                </a:solidFill>
+              </a:rPr>
+              <a:t>www.rawenglish.com.br</a:t>
+            </a:r>
+          </a:p>
+        </p:txBody>
+      </p:sp>
+    </p:spTree>
   </p:cSld>
   <p:clrMapOvr>
     <a:masterClrMapping/>
@@ -23741,7 +27689,7 @@
                   <a:schemeClr val="bg1"/>
                 </a:solidFill>
               </a:rPr>
-              <a:t>Kitchen</a:t>
+              <a:t>kitchen</a:t>
             </a:r>
             <a:r>
               <a:rPr lang="pt-BR" sz="2400" dirty="0">

</xml_diff>